<commit_message>
Align Lab 11 with group project and publish revised theory/practical slides
</commit_message>
<xml_diff>
--- a/slides/LAB11_RAG_pgvector_Bukti_Live.pptx
+++ b/slides/LAB11_RAG_pgvector_Bukti_Live.pptx
@@ -2,34 +2,34 @@
 <file path=ppt/presentation.xml><?xml version="1.0" encoding="utf-8"?>
 <p:presentation xmlns:p="http://schemas.openxmlformats.org/presentationml/2006/main">
   <p:sldMasterIdLst>
-    <p:sldMasterId xmlns:r="http://schemas.openxmlformats.org/officeDocument/2006/relationships" id="2147483648" r:id="Rdcd823dab9214a00"/>
+    <p:sldMasterId xmlns:r="http://schemas.openxmlformats.org/officeDocument/2006/relationships" id="2147483648" r:id="Rd34aacb498e24524"/>
   </p:sldMasterIdLst>
   <p:notesMasterIdLst>
-    <p:notesMasterId xmlns:r="http://schemas.openxmlformats.org/officeDocument/2006/relationships" r:id="Rcbcb1af9191b444e"/>
+    <p:notesMasterId xmlns:r="http://schemas.openxmlformats.org/officeDocument/2006/relationships" r:id="Rad67580782a04854"/>
   </p:notesMasterIdLst>
   <p:sldIdLst>
-    <p:sldId xmlns:r="http://schemas.openxmlformats.org/officeDocument/2006/relationships" id="256" r:id="Rb81511b671e14548"/>
-    <p:sldId xmlns:r="http://schemas.openxmlformats.org/officeDocument/2006/relationships" id="257" r:id="Re9280062d0ff429d"/>
-    <p:sldId xmlns:r="http://schemas.openxmlformats.org/officeDocument/2006/relationships" id="258" r:id="Rcf4ab13e8d314143"/>
-    <p:sldId xmlns:r="http://schemas.openxmlformats.org/officeDocument/2006/relationships" id="259" r:id="R6a1a4585d9f44b2f"/>
-    <p:sldId xmlns:r="http://schemas.openxmlformats.org/officeDocument/2006/relationships" id="260" r:id="R654e691c82e74011"/>
-    <p:sldId xmlns:r="http://schemas.openxmlformats.org/officeDocument/2006/relationships" id="261" r:id="Rdd2e95c38cc64a8c"/>
-    <p:sldId xmlns:r="http://schemas.openxmlformats.org/officeDocument/2006/relationships" id="262" r:id="R3d24dad58f314943"/>
-    <p:sldId xmlns:r="http://schemas.openxmlformats.org/officeDocument/2006/relationships" id="263" r:id="R42470436f76f4e26"/>
-    <p:sldId xmlns:r="http://schemas.openxmlformats.org/officeDocument/2006/relationships" id="264" r:id="Rbb45cda7278e4555"/>
-    <p:sldId xmlns:r="http://schemas.openxmlformats.org/officeDocument/2006/relationships" id="265" r:id="R5b423059b021420f"/>
-    <p:sldId xmlns:r="http://schemas.openxmlformats.org/officeDocument/2006/relationships" id="266" r:id="Ref6a6aae5cb64df9"/>
-    <p:sldId xmlns:r="http://schemas.openxmlformats.org/officeDocument/2006/relationships" id="267" r:id="R10a6e454159a448d"/>
-    <p:sldId xmlns:r="http://schemas.openxmlformats.org/officeDocument/2006/relationships" id="268" r:id="R6754dd0275ef4f43"/>
-    <p:sldId xmlns:r="http://schemas.openxmlformats.org/officeDocument/2006/relationships" id="269" r:id="R2135302bc45f447b"/>
-    <p:sldId xmlns:r="http://schemas.openxmlformats.org/officeDocument/2006/relationships" id="270" r:id="Rb7ea79c046ea4c5a"/>
-    <p:sldId xmlns:r="http://schemas.openxmlformats.org/officeDocument/2006/relationships" id="271" r:id="R6916491a24b142d5"/>
-    <p:sldId xmlns:r="http://schemas.openxmlformats.org/officeDocument/2006/relationships" id="272" r:id="Rafab212e0a1a45c3"/>
-    <p:sldId xmlns:r="http://schemas.openxmlformats.org/officeDocument/2006/relationships" id="273" r:id="R2185f524686f4263"/>
-    <p:sldId xmlns:r="http://schemas.openxmlformats.org/officeDocument/2006/relationships" id="274" r:id="R6dc759a54100490c"/>
-    <p:sldId xmlns:r="http://schemas.openxmlformats.org/officeDocument/2006/relationships" id="275" r:id="Rf45198361ebd41e7"/>
-    <p:sldId xmlns:r="http://schemas.openxmlformats.org/officeDocument/2006/relationships" id="276" r:id="R463c9c083e9a4b91"/>
-    <p:sldId xmlns:r="http://schemas.openxmlformats.org/officeDocument/2006/relationships" id="277" r:id="R17cdf37e27234d10"/>
+    <p:sldId xmlns:r="http://schemas.openxmlformats.org/officeDocument/2006/relationships" id="256" r:id="R01ad9adc3ff14004"/>
+    <p:sldId xmlns:r="http://schemas.openxmlformats.org/officeDocument/2006/relationships" id="257" r:id="Re63b4e83ea3944ed"/>
+    <p:sldId xmlns:r="http://schemas.openxmlformats.org/officeDocument/2006/relationships" id="258" r:id="Rac5c6e320bdc462f"/>
+    <p:sldId xmlns:r="http://schemas.openxmlformats.org/officeDocument/2006/relationships" id="259" r:id="R536e3b6666704173"/>
+    <p:sldId xmlns:r="http://schemas.openxmlformats.org/officeDocument/2006/relationships" id="260" r:id="R00c8aa9b352c482d"/>
+    <p:sldId xmlns:r="http://schemas.openxmlformats.org/officeDocument/2006/relationships" id="261" r:id="R96b3b192f41c447e"/>
+    <p:sldId xmlns:r="http://schemas.openxmlformats.org/officeDocument/2006/relationships" id="262" r:id="R48cb029463774f8c"/>
+    <p:sldId xmlns:r="http://schemas.openxmlformats.org/officeDocument/2006/relationships" id="263" r:id="R3dcd17cf509547ff"/>
+    <p:sldId xmlns:r="http://schemas.openxmlformats.org/officeDocument/2006/relationships" id="264" r:id="R63680d51f15b48d6"/>
+    <p:sldId xmlns:r="http://schemas.openxmlformats.org/officeDocument/2006/relationships" id="265" r:id="R3ab3d375df1f42fd"/>
+    <p:sldId xmlns:r="http://schemas.openxmlformats.org/officeDocument/2006/relationships" id="266" r:id="R05cc608a3b4b4a02"/>
+    <p:sldId xmlns:r="http://schemas.openxmlformats.org/officeDocument/2006/relationships" id="267" r:id="Rf07f6346177144e6"/>
+    <p:sldId xmlns:r="http://schemas.openxmlformats.org/officeDocument/2006/relationships" id="268" r:id="R6c7337b3bd6148f6"/>
+    <p:sldId xmlns:r="http://schemas.openxmlformats.org/officeDocument/2006/relationships" id="269" r:id="Rb424d4173e374153"/>
+    <p:sldId xmlns:r="http://schemas.openxmlformats.org/officeDocument/2006/relationships" id="270" r:id="Rb402d6e8f89a4e36"/>
+    <p:sldId xmlns:r="http://schemas.openxmlformats.org/officeDocument/2006/relationships" id="271" r:id="R224c3d937a214a45"/>
+    <p:sldId xmlns:r="http://schemas.openxmlformats.org/officeDocument/2006/relationships" id="272" r:id="Rf1e848388ed14fb7"/>
+    <p:sldId xmlns:r="http://schemas.openxmlformats.org/officeDocument/2006/relationships" id="273" r:id="Rc57b19b0b8514f34"/>
+    <p:sldId xmlns:r="http://schemas.openxmlformats.org/officeDocument/2006/relationships" id="274" r:id="Ra406c520d7454966"/>
+    <p:sldId xmlns:r="http://schemas.openxmlformats.org/officeDocument/2006/relationships" id="275" r:id="R2b64e3f1f2774f92"/>
+    <p:sldId xmlns:r="http://schemas.openxmlformats.org/officeDocument/2006/relationships" id="276" r:id="Rf275db4c00d54efe"/>
+    <p:sldId xmlns:r="http://schemas.openxmlformats.org/officeDocument/2006/relationships" id="277" r:id="R28105399fbb243af"/>
   </p:sldIdLst>
   <p:sldSz cx="12192000" cy="6858000"/>
   <p:notesSz cx="6858000" cy="9144000"/>
@@ -1998,7 +1998,7 @@
   </p:cSld>
   <p:clrMap bg1="lt1" tx1="dk1" bg2="lt2" tx2="dk2" accent1="accent1" accent2="accent2" accent3="accent3" accent4="accent4" accent5="accent5" accent6="accent6" hlink="hlink" folHlink="folHlink"/>
   <p:sldLayoutIdLst>
-    <p:sldLayoutId xmlns:r="http://schemas.openxmlformats.org/officeDocument/2006/relationships" id="2147483649" r:id="R2404d73339204c88"/>
+    <p:sldLayoutId xmlns:r="http://schemas.openxmlformats.org/officeDocument/2006/relationships" id="2147483649" r:id="R1fd5b12af28946c6"/>
   </p:sldLayoutIdLst>
   <p:hf sldNum="0" hdr="0" ftr="0" dt="0"/>
   <p:txStyles>
@@ -2551,7 +2551,7 @@
     <p:bg>
       <p:bgPr>
         <a:blipFill xmlns:a="http://schemas.openxmlformats.org/drawingml/2006/main" rotWithShape="1">
-          <a:blip xmlns:r="http://schemas.openxmlformats.org/officeDocument/2006/relationships" r:embed="R138b1bf0b42c41f0">
+          <a:blip xmlns:r="http://schemas.openxmlformats.org/officeDocument/2006/relationships" r:embed="R766a8cb47ec546c0">
             <a:lum/>
           </a:blip>
           <a:srcRect l="0" t="0" r="0" b="0"/>
@@ -2579,7 +2579,7 @@
           <p:nvPr/>
         </p:nvPicPr>
         <p:blipFill>
-          <a:blip xmlns:r="http://schemas.openxmlformats.org/officeDocument/2006/relationships" xmlns:a="http://schemas.openxmlformats.org/drawingml/2006/main" r:embed="Ra6b26f65c5ee46cf"/>
+          <a:blip xmlns:r="http://schemas.openxmlformats.org/officeDocument/2006/relationships" xmlns:a="http://schemas.openxmlformats.org/drawingml/2006/main" r:embed="R3eee44ddd8ae44f2"/>
           <a:stretch xmlns:a="http://schemas.openxmlformats.org/drawingml/2006/main">
             <a:fillRect l="0" t="0" r="0" b="0"/>
           </a:stretch>
@@ -2603,7 +2603,7 @@
           <p:nvPr/>
         </p:nvPicPr>
         <p:blipFill>
-          <a:blip xmlns:r="http://schemas.openxmlformats.org/officeDocument/2006/relationships" xmlns:a="http://schemas.openxmlformats.org/drawingml/2006/main" r:embed="R7012c7feb75d4b4c"/>
+          <a:blip xmlns:r="http://schemas.openxmlformats.org/officeDocument/2006/relationships" xmlns:a="http://schemas.openxmlformats.org/drawingml/2006/main" r:embed="Rc80baa8735554fb5"/>
           <a:stretch xmlns:a="http://schemas.openxmlformats.org/drawingml/2006/main">
             <a:fillRect l="0" t="0" r="0" b="0"/>
           </a:stretch>
@@ -3192,7 +3192,7 @@
           <p:nvPr/>
         </p:nvPicPr>
         <p:blipFill>
-          <a:blip xmlns:r="http://schemas.openxmlformats.org/officeDocument/2006/relationships" xmlns:a="http://schemas.openxmlformats.org/drawingml/2006/main" r:embed="R12a19dbb876545d7"/>
+          <a:blip xmlns:r="http://schemas.openxmlformats.org/officeDocument/2006/relationships" xmlns:a="http://schemas.openxmlformats.org/drawingml/2006/main" r:embed="R79b331ffcc0d467f"/>
           <a:stretch xmlns:a="http://schemas.openxmlformats.org/drawingml/2006/main">
             <a:fillRect l="0" t="0" r="0" b="0"/>
           </a:stretch>
@@ -3216,7 +3216,7 @@
           <p:nvPr/>
         </p:nvPicPr>
         <p:blipFill>
-          <a:blip xmlns:r="http://schemas.openxmlformats.org/officeDocument/2006/relationships" xmlns:a="http://schemas.openxmlformats.org/drawingml/2006/main" r:embed="Re33bcf69e63d4d8b"/>
+          <a:blip xmlns:r="http://schemas.openxmlformats.org/officeDocument/2006/relationships" xmlns:a="http://schemas.openxmlformats.org/drawingml/2006/main" r:embed="R96806063ccfb4f2f"/>
           <a:stretch xmlns:a="http://schemas.openxmlformats.org/drawingml/2006/main">
             <a:fillRect l="0" t="0" r="0" b="0"/>
           </a:stretch>
@@ -4139,7 +4139,7 @@
           <p:nvPr/>
         </p:nvPicPr>
         <p:blipFill>
-          <a:blip xmlns:r="http://schemas.openxmlformats.org/officeDocument/2006/relationships" xmlns:a="http://schemas.openxmlformats.org/drawingml/2006/main" r:embed="R5e70577ff37a4f97"/>
+          <a:blip xmlns:r="http://schemas.openxmlformats.org/officeDocument/2006/relationships" xmlns:a="http://schemas.openxmlformats.org/drawingml/2006/main" r:embed="R2a4db55654a343f6"/>
           <a:stretch xmlns:a="http://schemas.openxmlformats.org/drawingml/2006/main">
             <a:fillRect l="0" t="0" r="0" b="0"/>
           </a:stretch>
@@ -4163,7 +4163,7 @@
           <p:nvPr/>
         </p:nvPicPr>
         <p:blipFill>
-          <a:blip xmlns:r="http://schemas.openxmlformats.org/officeDocument/2006/relationships" xmlns:a="http://schemas.openxmlformats.org/drawingml/2006/main" r:embed="Rc7443a6bda364dee"/>
+          <a:blip xmlns:r="http://schemas.openxmlformats.org/officeDocument/2006/relationships" xmlns:a="http://schemas.openxmlformats.org/drawingml/2006/main" r:embed="Rfcb68853a3184d63"/>
           <a:stretch xmlns:a="http://schemas.openxmlformats.org/drawingml/2006/main">
             <a:fillRect l="0" t="0" r="0" b="0"/>
           </a:stretch>
@@ -4399,7 +4399,7 @@
           <p:nvPr/>
         </p:nvPicPr>
         <p:blipFill>
-          <a:blip xmlns:r="http://schemas.openxmlformats.org/officeDocument/2006/relationships" xmlns:a="http://schemas.openxmlformats.org/drawingml/2006/main" r:embed="Rb847a6894fdc471b"/>
+          <a:blip xmlns:r="http://schemas.openxmlformats.org/officeDocument/2006/relationships" xmlns:a="http://schemas.openxmlformats.org/drawingml/2006/main" r:embed="Rd939c131b9384406"/>
           <a:stretch xmlns:a="http://schemas.openxmlformats.org/drawingml/2006/main">
             <a:fillRect l="0" t="0" r="0" b="0"/>
           </a:stretch>
@@ -4476,7 +4476,7 @@
           <p:nvPr/>
         </p:nvPicPr>
         <p:blipFill>
-          <a:blip xmlns:r="http://schemas.openxmlformats.org/officeDocument/2006/relationships" xmlns:a="http://schemas.openxmlformats.org/drawingml/2006/main" r:embed="Rf1024a12950e4e0f"/>
+          <a:blip xmlns:r="http://schemas.openxmlformats.org/officeDocument/2006/relationships" xmlns:a="http://schemas.openxmlformats.org/drawingml/2006/main" r:embed="R1baeafcc75ca42fe"/>
           <a:stretch xmlns:a="http://schemas.openxmlformats.org/drawingml/2006/main">
             <a:fillRect l="0" t="0" r="0" b="0"/>
           </a:stretch>
@@ -4553,7 +4553,7 @@
           <p:nvPr/>
         </p:nvPicPr>
         <p:blipFill>
-          <a:blip xmlns:r="http://schemas.openxmlformats.org/officeDocument/2006/relationships" xmlns:a="http://schemas.openxmlformats.org/drawingml/2006/main" r:embed="Rd47a29455790439f"/>
+          <a:blip xmlns:r="http://schemas.openxmlformats.org/officeDocument/2006/relationships" xmlns:a="http://schemas.openxmlformats.org/drawingml/2006/main" r:embed="R7a41e260437c4875"/>
           <a:stretch xmlns:a="http://schemas.openxmlformats.org/drawingml/2006/main">
             <a:fillRect l="0" t="0" r="0" b="0"/>
           </a:stretch>
@@ -4630,7 +4630,7 @@
           <p:nvPr/>
         </p:nvPicPr>
         <p:blipFill>
-          <a:blip xmlns:r="http://schemas.openxmlformats.org/officeDocument/2006/relationships" xmlns:a="http://schemas.openxmlformats.org/drawingml/2006/main" r:embed="R5c8f717f23244686"/>
+          <a:blip xmlns:r="http://schemas.openxmlformats.org/officeDocument/2006/relationships" xmlns:a="http://schemas.openxmlformats.org/drawingml/2006/main" r:embed="R92000b4dd8264ac2"/>
           <a:stretch xmlns:a="http://schemas.openxmlformats.org/drawingml/2006/main">
             <a:fillRect l="0" t="0" r="0" b="0"/>
           </a:stretch>
@@ -4707,7 +4707,7 @@
           <p:nvPr/>
         </p:nvPicPr>
         <p:blipFill>
-          <a:blip xmlns:r="http://schemas.openxmlformats.org/officeDocument/2006/relationships" xmlns:a="http://schemas.openxmlformats.org/drawingml/2006/main" r:embed="R303aedc0235848d1"/>
+          <a:blip xmlns:r="http://schemas.openxmlformats.org/officeDocument/2006/relationships" xmlns:a="http://schemas.openxmlformats.org/drawingml/2006/main" r:embed="Rd06d36b617ca484e"/>
           <a:stretch xmlns:a="http://schemas.openxmlformats.org/drawingml/2006/main">
             <a:fillRect l="0" t="0" r="0" b="0"/>
           </a:stretch>
@@ -4784,7 +4784,7 @@
           <p:nvPr/>
         </p:nvPicPr>
         <p:blipFill>
-          <a:blip xmlns:r="http://schemas.openxmlformats.org/officeDocument/2006/relationships" xmlns:a="http://schemas.openxmlformats.org/drawingml/2006/main" r:embed="R836da5f570304944"/>
+          <a:blip xmlns:r="http://schemas.openxmlformats.org/officeDocument/2006/relationships" xmlns:a="http://schemas.openxmlformats.org/drawingml/2006/main" r:embed="Ra3d8b5720a56435c"/>
           <a:stretch xmlns:a="http://schemas.openxmlformats.org/drawingml/2006/main">
             <a:fillRect l="0" t="0" r="0" b="0"/>
           </a:stretch>
@@ -4861,7 +4861,7 @@
           <p:nvPr/>
         </p:nvPicPr>
         <p:blipFill>
-          <a:blip xmlns:r="http://schemas.openxmlformats.org/officeDocument/2006/relationships" xmlns:a="http://schemas.openxmlformats.org/drawingml/2006/main" r:embed="R489f328d27d04274"/>
+          <a:blip xmlns:r="http://schemas.openxmlformats.org/officeDocument/2006/relationships" xmlns:a="http://schemas.openxmlformats.org/drawingml/2006/main" r:embed="R056063c4ac264eb4"/>
           <a:stretch xmlns:a="http://schemas.openxmlformats.org/drawingml/2006/main">
             <a:fillRect l="0" t="0" r="0" b="0"/>
           </a:stretch>
@@ -5151,7 +5151,7 @@
           <p:nvPr/>
         </p:nvPicPr>
         <p:blipFill>
-          <a:blip xmlns:r="http://schemas.openxmlformats.org/officeDocument/2006/relationships" xmlns:a="http://schemas.openxmlformats.org/drawingml/2006/main" r:embed="R8bacc3160658442b"/>
+          <a:blip xmlns:r="http://schemas.openxmlformats.org/officeDocument/2006/relationships" xmlns:a="http://schemas.openxmlformats.org/drawingml/2006/main" r:embed="R34d5f12f0ffd4738"/>
           <a:stretch xmlns:a="http://schemas.openxmlformats.org/drawingml/2006/main">
             <a:fillRect l="0" t="0" r="0" b="0"/>
           </a:stretch>
@@ -5334,7 +5334,7 @@
           <p:nvPr/>
         </p:nvPicPr>
         <p:blipFill>
-          <a:blip xmlns:r="http://schemas.openxmlformats.org/officeDocument/2006/relationships" xmlns:a="http://schemas.openxmlformats.org/drawingml/2006/main" r:embed="R2f5d4df64ad54640"/>
+          <a:blip xmlns:r="http://schemas.openxmlformats.org/officeDocument/2006/relationships" xmlns:a="http://schemas.openxmlformats.org/drawingml/2006/main" r:embed="R4f7a929398c54535"/>
           <a:stretch xmlns:a="http://schemas.openxmlformats.org/drawingml/2006/main">
             <a:fillRect l="0" t="0" r="0" b="0"/>
           </a:stretch>
@@ -5358,7 +5358,7 @@
           <p:nvPr/>
         </p:nvPicPr>
         <p:blipFill>
-          <a:blip xmlns:r="http://schemas.openxmlformats.org/officeDocument/2006/relationships" xmlns:a="http://schemas.openxmlformats.org/drawingml/2006/main" r:embed="R15555eaad5764e6b"/>
+          <a:blip xmlns:r="http://schemas.openxmlformats.org/officeDocument/2006/relationships" xmlns:a="http://schemas.openxmlformats.org/drawingml/2006/main" r:embed="R50286fdeca734280"/>
           <a:stretch xmlns:a="http://schemas.openxmlformats.org/drawingml/2006/main">
             <a:fillRect l="0" t="0" r="0" b="0"/>
           </a:stretch>
@@ -6285,7 +6285,7 @@
           <p:nvPr/>
         </p:nvPicPr>
         <p:blipFill>
-          <a:blip xmlns:r="http://schemas.openxmlformats.org/officeDocument/2006/relationships" xmlns:a="http://schemas.openxmlformats.org/drawingml/2006/main" r:embed="Rb8125d6b19b84597"/>
+          <a:blip xmlns:r="http://schemas.openxmlformats.org/officeDocument/2006/relationships" xmlns:a="http://schemas.openxmlformats.org/drawingml/2006/main" r:embed="R59c9622972bc4bab"/>
           <a:stretch xmlns:a="http://schemas.openxmlformats.org/drawingml/2006/main">
             <a:fillRect l="0" t="0" r="0" b="0"/>
           </a:stretch>
@@ -6309,7 +6309,7 @@
           <p:nvPr/>
         </p:nvPicPr>
         <p:blipFill>
-          <a:blip xmlns:r="http://schemas.openxmlformats.org/officeDocument/2006/relationships" xmlns:a="http://schemas.openxmlformats.org/drawingml/2006/main" r:embed="R45e4dae82e7a4b6f"/>
+          <a:blip xmlns:r="http://schemas.openxmlformats.org/officeDocument/2006/relationships" xmlns:a="http://schemas.openxmlformats.org/drawingml/2006/main" r:embed="R5f14d3cb34dc46df"/>
           <a:stretch xmlns:a="http://schemas.openxmlformats.org/drawingml/2006/main">
             <a:fillRect l="0" t="0" r="0" b="0"/>
           </a:stretch>
@@ -6545,7 +6545,7 @@
           <p:nvPr/>
         </p:nvPicPr>
         <p:blipFill>
-          <a:blip xmlns:r="http://schemas.openxmlformats.org/officeDocument/2006/relationships" xmlns:a="http://schemas.openxmlformats.org/drawingml/2006/main" r:embed="Rc6e2ea5306504d13"/>
+          <a:blip xmlns:r="http://schemas.openxmlformats.org/officeDocument/2006/relationships" xmlns:a="http://schemas.openxmlformats.org/drawingml/2006/main" r:embed="Rbd7d105dcaa541dc"/>
           <a:stretch xmlns:a="http://schemas.openxmlformats.org/drawingml/2006/main">
             <a:fillRect l="0" t="0" r="0" b="0"/>
           </a:stretch>
@@ -6622,7 +6622,7 @@
           <p:nvPr/>
         </p:nvPicPr>
         <p:blipFill>
-          <a:blip xmlns:r="http://schemas.openxmlformats.org/officeDocument/2006/relationships" xmlns:a="http://schemas.openxmlformats.org/drawingml/2006/main" r:embed="R3f1ca30cf38e4fb7"/>
+          <a:blip xmlns:r="http://schemas.openxmlformats.org/officeDocument/2006/relationships" xmlns:a="http://schemas.openxmlformats.org/drawingml/2006/main" r:embed="R1e07589da06146ec"/>
           <a:stretch xmlns:a="http://schemas.openxmlformats.org/drawingml/2006/main">
             <a:fillRect l="0" t="0" r="0" b="0"/>
           </a:stretch>
@@ -6699,7 +6699,7 @@
           <p:nvPr/>
         </p:nvPicPr>
         <p:blipFill>
-          <a:blip xmlns:r="http://schemas.openxmlformats.org/officeDocument/2006/relationships" xmlns:a="http://schemas.openxmlformats.org/drawingml/2006/main" r:embed="Rc8671f4ad04e42cb"/>
+          <a:blip xmlns:r="http://schemas.openxmlformats.org/officeDocument/2006/relationships" xmlns:a="http://schemas.openxmlformats.org/drawingml/2006/main" r:embed="R6bd37d065a50450c"/>
           <a:stretch xmlns:a="http://schemas.openxmlformats.org/drawingml/2006/main">
             <a:fillRect l="0" t="0" r="0" b="0"/>
           </a:stretch>
@@ -6776,7 +6776,7 @@
           <p:nvPr/>
         </p:nvPicPr>
         <p:blipFill>
-          <a:blip xmlns:r="http://schemas.openxmlformats.org/officeDocument/2006/relationships" xmlns:a="http://schemas.openxmlformats.org/drawingml/2006/main" r:embed="R225a9530247a449d"/>
+          <a:blip xmlns:r="http://schemas.openxmlformats.org/officeDocument/2006/relationships" xmlns:a="http://schemas.openxmlformats.org/drawingml/2006/main" r:embed="Rae22a790b7dc42e7"/>
           <a:stretch xmlns:a="http://schemas.openxmlformats.org/drawingml/2006/main">
             <a:fillRect l="0" t="0" r="0" b="0"/>
           </a:stretch>
@@ -6853,7 +6853,7 @@
           <p:nvPr/>
         </p:nvPicPr>
         <p:blipFill>
-          <a:blip xmlns:r="http://schemas.openxmlformats.org/officeDocument/2006/relationships" xmlns:a="http://schemas.openxmlformats.org/drawingml/2006/main" r:embed="R1c9e82fabe454a59"/>
+          <a:blip xmlns:r="http://schemas.openxmlformats.org/officeDocument/2006/relationships" xmlns:a="http://schemas.openxmlformats.org/drawingml/2006/main" r:embed="R1b3cfa09ed294751"/>
           <a:stretch xmlns:a="http://schemas.openxmlformats.org/drawingml/2006/main">
             <a:fillRect l="0" t="0" r="0" b="0"/>
           </a:stretch>
@@ -6930,7 +6930,7 @@
           <p:nvPr/>
         </p:nvPicPr>
         <p:blipFill>
-          <a:blip xmlns:r="http://schemas.openxmlformats.org/officeDocument/2006/relationships" xmlns:a="http://schemas.openxmlformats.org/drawingml/2006/main" r:embed="R02b619d7e1bb4ec5"/>
+          <a:blip xmlns:r="http://schemas.openxmlformats.org/officeDocument/2006/relationships" xmlns:a="http://schemas.openxmlformats.org/drawingml/2006/main" r:embed="Rbb196357833d4a51"/>
           <a:stretch xmlns:a="http://schemas.openxmlformats.org/drawingml/2006/main">
             <a:fillRect l="0" t="0" r="0" b="0"/>
           </a:stretch>
@@ -7007,7 +7007,7 @@
           <p:nvPr/>
         </p:nvPicPr>
         <p:blipFill>
-          <a:blip xmlns:r="http://schemas.openxmlformats.org/officeDocument/2006/relationships" xmlns:a="http://schemas.openxmlformats.org/drawingml/2006/main" r:embed="Rdb22e56db7654426"/>
+          <a:blip xmlns:r="http://schemas.openxmlformats.org/officeDocument/2006/relationships" xmlns:a="http://schemas.openxmlformats.org/drawingml/2006/main" r:embed="R34d0a1ae6d164745"/>
           <a:stretch xmlns:a="http://schemas.openxmlformats.org/drawingml/2006/main">
             <a:fillRect l="0" t="0" r="0" b="0"/>
           </a:stretch>
@@ -7297,7 +7297,7 @@
           <p:nvPr/>
         </p:nvPicPr>
         <p:blipFill>
-          <a:blip xmlns:r="http://schemas.openxmlformats.org/officeDocument/2006/relationships" xmlns:a="http://schemas.openxmlformats.org/drawingml/2006/main" r:embed="Rfc34e92e1e3b4f4d"/>
+          <a:blip xmlns:r="http://schemas.openxmlformats.org/officeDocument/2006/relationships" xmlns:a="http://schemas.openxmlformats.org/drawingml/2006/main" r:embed="Ref4f6b5732c74a2d"/>
           <a:stretch xmlns:a="http://schemas.openxmlformats.org/drawingml/2006/main">
             <a:fillRect l="0" t="0" r="0" b="0"/>
           </a:stretch>
@@ -7473,7 +7473,7 @@
           <p:nvPr/>
         </p:nvPicPr>
         <p:blipFill>
-          <a:blip xmlns:r="http://schemas.openxmlformats.org/officeDocument/2006/relationships" xmlns:a="http://schemas.openxmlformats.org/drawingml/2006/main" r:embed="R3fe989a4d7814569"/>
+          <a:blip xmlns:r="http://schemas.openxmlformats.org/officeDocument/2006/relationships" xmlns:a="http://schemas.openxmlformats.org/drawingml/2006/main" r:embed="Re8ebdf9a489f453c"/>
           <a:stretch xmlns:a="http://schemas.openxmlformats.org/drawingml/2006/main">
             <a:fillRect l="0" t="0" r="0" b="0"/>
           </a:stretch>
@@ -7497,7 +7497,7 @@
           <p:nvPr/>
         </p:nvPicPr>
         <p:blipFill>
-          <a:blip xmlns:r="http://schemas.openxmlformats.org/officeDocument/2006/relationships" xmlns:a="http://schemas.openxmlformats.org/drawingml/2006/main" r:embed="Rf6c42f0578da4eb8"/>
+          <a:blip xmlns:r="http://schemas.openxmlformats.org/officeDocument/2006/relationships" xmlns:a="http://schemas.openxmlformats.org/drawingml/2006/main" r:embed="R997d6c67cac74cb5"/>
           <a:stretch xmlns:a="http://schemas.openxmlformats.org/drawingml/2006/main">
             <a:fillRect l="0" t="0" r="0" b="0"/>
           </a:stretch>
@@ -7733,7 +7733,7 @@
           <p:nvPr/>
         </p:nvPicPr>
         <p:blipFill>
-          <a:blip xmlns:r="http://schemas.openxmlformats.org/officeDocument/2006/relationships" xmlns:a="http://schemas.openxmlformats.org/drawingml/2006/main" r:embed="Rc1bf0226dc484977"/>
+          <a:blip xmlns:r="http://schemas.openxmlformats.org/officeDocument/2006/relationships" xmlns:a="http://schemas.openxmlformats.org/drawingml/2006/main" r:embed="Ra7151d87f10d466b"/>
           <a:stretch xmlns:a="http://schemas.openxmlformats.org/drawingml/2006/main">
             <a:fillRect l="0" t="0" r="0" b="0"/>
           </a:stretch>
@@ -7810,7 +7810,7 @@
           <p:nvPr/>
         </p:nvPicPr>
         <p:blipFill>
-          <a:blip xmlns:r="http://schemas.openxmlformats.org/officeDocument/2006/relationships" xmlns:a="http://schemas.openxmlformats.org/drawingml/2006/main" r:embed="R0f7f406dccd54270"/>
+          <a:blip xmlns:r="http://schemas.openxmlformats.org/officeDocument/2006/relationships" xmlns:a="http://schemas.openxmlformats.org/drawingml/2006/main" r:embed="Rd7e995559fe24339"/>
           <a:stretch xmlns:a="http://schemas.openxmlformats.org/drawingml/2006/main">
             <a:fillRect l="0" t="0" r="0" b="0"/>
           </a:stretch>
@@ -7887,7 +7887,7 @@
           <p:nvPr/>
         </p:nvPicPr>
         <p:blipFill>
-          <a:blip xmlns:r="http://schemas.openxmlformats.org/officeDocument/2006/relationships" xmlns:a="http://schemas.openxmlformats.org/drawingml/2006/main" r:embed="Rcd583444f9344924"/>
+          <a:blip xmlns:r="http://schemas.openxmlformats.org/officeDocument/2006/relationships" xmlns:a="http://schemas.openxmlformats.org/drawingml/2006/main" r:embed="Radda1bff781d4186"/>
           <a:stretch xmlns:a="http://schemas.openxmlformats.org/drawingml/2006/main">
             <a:fillRect l="0" t="0" r="0" b="0"/>
           </a:stretch>
@@ -7964,7 +7964,7 @@
           <p:nvPr/>
         </p:nvPicPr>
         <p:blipFill>
-          <a:blip xmlns:r="http://schemas.openxmlformats.org/officeDocument/2006/relationships" xmlns:a="http://schemas.openxmlformats.org/drawingml/2006/main" r:embed="R1977beb45a8f422a"/>
+          <a:blip xmlns:r="http://schemas.openxmlformats.org/officeDocument/2006/relationships" xmlns:a="http://schemas.openxmlformats.org/drawingml/2006/main" r:embed="R6c9b4d0ac1784b87"/>
           <a:stretch xmlns:a="http://schemas.openxmlformats.org/drawingml/2006/main">
             <a:fillRect l="0" t="0" r="0" b="0"/>
           </a:stretch>
@@ -8041,7 +8041,7 @@
           <p:nvPr/>
         </p:nvPicPr>
         <p:blipFill>
-          <a:blip xmlns:r="http://schemas.openxmlformats.org/officeDocument/2006/relationships" xmlns:a="http://schemas.openxmlformats.org/drawingml/2006/main" r:embed="Rbc8ff49399ad4d03"/>
+          <a:blip xmlns:r="http://schemas.openxmlformats.org/officeDocument/2006/relationships" xmlns:a="http://schemas.openxmlformats.org/drawingml/2006/main" r:embed="Rf54316ba365b4ca0"/>
           <a:stretch xmlns:a="http://schemas.openxmlformats.org/drawingml/2006/main">
             <a:fillRect l="0" t="0" r="0" b="0"/>
           </a:stretch>
@@ -8118,7 +8118,7 @@
           <p:nvPr/>
         </p:nvPicPr>
         <p:blipFill>
-          <a:blip xmlns:r="http://schemas.openxmlformats.org/officeDocument/2006/relationships" xmlns:a="http://schemas.openxmlformats.org/drawingml/2006/main" r:embed="Rce5adaa216ea4b8b"/>
+          <a:blip xmlns:r="http://schemas.openxmlformats.org/officeDocument/2006/relationships" xmlns:a="http://schemas.openxmlformats.org/drawingml/2006/main" r:embed="R3188e6bc6ace42fa"/>
           <a:stretch xmlns:a="http://schemas.openxmlformats.org/drawingml/2006/main">
             <a:fillRect l="0" t="0" r="0" b="0"/>
           </a:stretch>
@@ -8195,7 +8195,7 @@
           <p:nvPr/>
         </p:nvPicPr>
         <p:blipFill>
-          <a:blip xmlns:r="http://schemas.openxmlformats.org/officeDocument/2006/relationships" xmlns:a="http://schemas.openxmlformats.org/drawingml/2006/main" r:embed="R7d74e704cb894400"/>
+          <a:blip xmlns:r="http://schemas.openxmlformats.org/officeDocument/2006/relationships" xmlns:a="http://schemas.openxmlformats.org/drawingml/2006/main" r:embed="R7f541625b00f4e23"/>
           <a:stretch xmlns:a="http://schemas.openxmlformats.org/drawingml/2006/main">
             <a:fillRect l="0" t="0" r="0" b="0"/>
           </a:stretch>
@@ -8485,7 +8485,7 @@
           <p:nvPr/>
         </p:nvPicPr>
         <p:blipFill>
-          <a:blip xmlns:r="http://schemas.openxmlformats.org/officeDocument/2006/relationships" xmlns:a="http://schemas.openxmlformats.org/drawingml/2006/main" r:embed="Rfbc5470499164f53"/>
+          <a:blip xmlns:r="http://schemas.openxmlformats.org/officeDocument/2006/relationships" xmlns:a="http://schemas.openxmlformats.org/drawingml/2006/main" r:embed="R91a7472fb901449c"/>
           <a:stretch xmlns:a="http://schemas.openxmlformats.org/drawingml/2006/main">
             <a:fillRect l="0" t="0" r="0" b="0"/>
           </a:stretch>
@@ -8661,7 +8661,7 @@
           <p:nvPr/>
         </p:nvPicPr>
         <p:blipFill>
-          <a:blip xmlns:r="http://schemas.openxmlformats.org/officeDocument/2006/relationships" xmlns:a="http://schemas.openxmlformats.org/drawingml/2006/main" r:embed="R9f252af690d34eda"/>
+          <a:blip xmlns:r="http://schemas.openxmlformats.org/officeDocument/2006/relationships" xmlns:a="http://schemas.openxmlformats.org/drawingml/2006/main" r:embed="R8d578938250b4f82"/>
           <a:stretch xmlns:a="http://schemas.openxmlformats.org/drawingml/2006/main">
             <a:fillRect l="0" t="0" r="0" b="0"/>
           </a:stretch>
@@ -8685,7 +8685,7 @@
           <p:nvPr/>
         </p:nvPicPr>
         <p:blipFill>
-          <a:blip xmlns:r="http://schemas.openxmlformats.org/officeDocument/2006/relationships" xmlns:a="http://schemas.openxmlformats.org/drawingml/2006/main" r:embed="Raf5589ac33db44e2"/>
+          <a:blip xmlns:r="http://schemas.openxmlformats.org/officeDocument/2006/relationships" xmlns:a="http://schemas.openxmlformats.org/drawingml/2006/main" r:embed="Raf5cbe3b254d4f2f"/>
           <a:stretch xmlns:a="http://schemas.openxmlformats.org/drawingml/2006/main">
             <a:fillRect l="0" t="0" r="0" b="0"/>
           </a:stretch>
@@ -8921,7 +8921,7 @@
           <p:nvPr/>
         </p:nvPicPr>
         <p:blipFill>
-          <a:blip xmlns:r="http://schemas.openxmlformats.org/officeDocument/2006/relationships" xmlns:a="http://schemas.openxmlformats.org/drawingml/2006/main" r:embed="Rf529d6b07a844a4c"/>
+          <a:blip xmlns:r="http://schemas.openxmlformats.org/officeDocument/2006/relationships" xmlns:a="http://schemas.openxmlformats.org/drawingml/2006/main" r:embed="Rcd04d762ddb84f7e"/>
           <a:stretch xmlns:a="http://schemas.openxmlformats.org/drawingml/2006/main">
             <a:fillRect l="0" t="0" r="0" b="0"/>
           </a:stretch>
@@ -8998,7 +8998,7 @@
           <p:nvPr/>
         </p:nvPicPr>
         <p:blipFill>
-          <a:blip xmlns:r="http://schemas.openxmlformats.org/officeDocument/2006/relationships" xmlns:a="http://schemas.openxmlformats.org/drawingml/2006/main" r:embed="Ra25d09802726456a"/>
+          <a:blip xmlns:r="http://schemas.openxmlformats.org/officeDocument/2006/relationships" xmlns:a="http://schemas.openxmlformats.org/drawingml/2006/main" r:embed="R95cb7051ee66485d"/>
           <a:stretch xmlns:a="http://schemas.openxmlformats.org/drawingml/2006/main">
             <a:fillRect l="0" t="0" r="0" b="0"/>
           </a:stretch>
@@ -9075,7 +9075,7 @@
           <p:nvPr/>
         </p:nvPicPr>
         <p:blipFill>
-          <a:blip xmlns:r="http://schemas.openxmlformats.org/officeDocument/2006/relationships" xmlns:a="http://schemas.openxmlformats.org/drawingml/2006/main" r:embed="Rcaffae485cc74384"/>
+          <a:blip xmlns:r="http://schemas.openxmlformats.org/officeDocument/2006/relationships" xmlns:a="http://schemas.openxmlformats.org/drawingml/2006/main" r:embed="R248042cf3f7e46e0"/>
           <a:stretch xmlns:a="http://schemas.openxmlformats.org/drawingml/2006/main">
             <a:fillRect l="0" t="0" r="0" b="0"/>
           </a:stretch>
@@ -9152,7 +9152,7 @@
           <p:nvPr/>
         </p:nvPicPr>
         <p:blipFill>
-          <a:blip xmlns:r="http://schemas.openxmlformats.org/officeDocument/2006/relationships" xmlns:a="http://schemas.openxmlformats.org/drawingml/2006/main" r:embed="Rc230441d7e9b408b"/>
+          <a:blip xmlns:r="http://schemas.openxmlformats.org/officeDocument/2006/relationships" xmlns:a="http://schemas.openxmlformats.org/drawingml/2006/main" r:embed="Rd6c87412b29e4aad"/>
           <a:stretch xmlns:a="http://schemas.openxmlformats.org/drawingml/2006/main">
             <a:fillRect l="0" t="0" r="0" b="0"/>
           </a:stretch>
@@ -9229,7 +9229,7 @@
           <p:nvPr/>
         </p:nvPicPr>
         <p:blipFill>
-          <a:blip xmlns:r="http://schemas.openxmlformats.org/officeDocument/2006/relationships" xmlns:a="http://schemas.openxmlformats.org/drawingml/2006/main" r:embed="Rac5a19af79304c73"/>
+          <a:blip xmlns:r="http://schemas.openxmlformats.org/officeDocument/2006/relationships" xmlns:a="http://schemas.openxmlformats.org/drawingml/2006/main" r:embed="R43a9a1e1de594499"/>
           <a:stretch xmlns:a="http://schemas.openxmlformats.org/drawingml/2006/main">
             <a:fillRect l="0" t="0" r="0" b="0"/>
           </a:stretch>
@@ -9306,7 +9306,7 @@
           <p:nvPr/>
         </p:nvPicPr>
         <p:blipFill>
-          <a:blip xmlns:r="http://schemas.openxmlformats.org/officeDocument/2006/relationships" xmlns:a="http://schemas.openxmlformats.org/drawingml/2006/main" r:embed="Ra7c95d4b27644450"/>
+          <a:blip xmlns:r="http://schemas.openxmlformats.org/officeDocument/2006/relationships" xmlns:a="http://schemas.openxmlformats.org/drawingml/2006/main" r:embed="R06c28a7ba85c4088"/>
           <a:stretch xmlns:a="http://schemas.openxmlformats.org/drawingml/2006/main">
             <a:fillRect l="0" t="0" r="0" b="0"/>
           </a:stretch>
@@ -9383,7 +9383,7 @@
           <p:nvPr/>
         </p:nvPicPr>
         <p:blipFill>
-          <a:blip xmlns:r="http://schemas.openxmlformats.org/officeDocument/2006/relationships" xmlns:a="http://schemas.openxmlformats.org/drawingml/2006/main" r:embed="R591a7b3123bf4de5"/>
+          <a:blip xmlns:r="http://schemas.openxmlformats.org/officeDocument/2006/relationships" xmlns:a="http://schemas.openxmlformats.org/drawingml/2006/main" r:embed="R5ec95af80b8e4f8c"/>
           <a:stretch xmlns:a="http://schemas.openxmlformats.org/drawingml/2006/main">
             <a:fillRect l="0" t="0" r="0" b="0"/>
           </a:stretch>
@@ -9673,7 +9673,7 @@
           <p:nvPr/>
         </p:nvPicPr>
         <p:blipFill>
-          <a:blip xmlns:r="http://schemas.openxmlformats.org/officeDocument/2006/relationships" xmlns:a="http://schemas.openxmlformats.org/drawingml/2006/main" r:embed="Red6c7c4db36d4f09"/>
+          <a:blip xmlns:r="http://schemas.openxmlformats.org/officeDocument/2006/relationships" xmlns:a="http://schemas.openxmlformats.org/drawingml/2006/main" r:embed="Rf1b02baebe5a44e2"/>
           <a:stretch xmlns:a="http://schemas.openxmlformats.org/drawingml/2006/main">
             <a:fillRect l="0" t="0" r="0" b="0"/>
           </a:stretch>
@@ -9856,7 +9856,7 @@
           <p:nvPr/>
         </p:nvPicPr>
         <p:blipFill>
-          <a:blip xmlns:r="http://schemas.openxmlformats.org/officeDocument/2006/relationships" xmlns:a="http://schemas.openxmlformats.org/drawingml/2006/main" r:embed="Rd8d5e5eb6649465c"/>
+          <a:blip xmlns:r="http://schemas.openxmlformats.org/officeDocument/2006/relationships" xmlns:a="http://schemas.openxmlformats.org/drawingml/2006/main" r:embed="R08ec4d3369744dea"/>
           <a:stretch xmlns:a="http://schemas.openxmlformats.org/drawingml/2006/main">
             <a:fillRect l="0" t="0" r="0" b="0"/>
           </a:stretch>
@@ -9880,7 +9880,7 @@
           <p:nvPr/>
         </p:nvPicPr>
         <p:blipFill>
-          <a:blip xmlns:r="http://schemas.openxmlformats.org/officeDocument/2006/relationships" xmlns:a="http://schemas.openxmlformats.org/drawingml/2006/main" r:embed="R671772d4b1504932"/>
+          <a:blip xmlns:r="http://schemas.openxmlformats.org/officeDocument/2006/relationships" xmlns:a="http://schemas.openxmlformats.org/drawingml/2006/main" r:embed="R80860b9bbcc446c5"/>
           <a:stretch xmlns:a="http://schemas.openxmlformats.org/drawingml/2006/main">
             <a:fillRect l="0" t="0" r="0" b="0"/>
           </a:stretch>
@@ -10804,7 +10804,7 @@
           <p:nvPr/>
         </p:nvPicPr>
         <p:blipFill>
-          <a:blip xmlns:r="http://schemas.openxmlformats.org/officeDocument/2006/relationships" xmlns:a="http://schemas.openxmlformats.org/drawingml/2006/main" r:embed="R87cae14db5394b0b"/>
+          <a:blip xmlns:r="http://schemas.openxmlformats.org/officeDocument/2006/relationships" xmlns:a="http://schemas.openxmlformats.org/drawingml/2006/main" r:embed="Raecd0a9bdb414799"/>
           <a:stretch xmlns:a="http://schemas.openxmlformats.org/drawingml/2006/main">
             <a:fillRect l="0" t="0" r="0" b="0"/>
           </a:stretch>
@@ -10828,7 +10828,7 @@
           <p:nvPr/>
         </p:nvPicPr>
         <p:blipFill>
-          <a:blip xmlns:r="http://schemas.openxmlformats.org/officeDocument/2006/relationships" xmlns:a="http://schemas.openxmlformats.org/drawingml/2006/main" r:embed="R80aba89fbb984f86"/>
+          <a:blip xmlns:r="http://schemas.openxmlformats.org/officeDocument/2006/relationships" xmlns:a="http://schemas.openxmlformats.org/drawingml/2006/main" r:embed="Rf47729dc93ac4202"/>
           <a:stretch xmlns:a="http://schemas.openxmlformats.org/drawingml/2006/main">
             <a:fillRect l="0" t="0" r="0" b="0"/>
           </a:stretch>
@@ -11064,7 +11064,7 @@
           <p:nvPr/>
         </p:nvPicPr>
         <p:blipFill>
-          <a:blip xmlns:r="http://schemas.openxmlformats.org/officeDocument/2006/relationships" xmlns:a="http://schemas.openxmlformats.org/drawingml/2006/main" r:embed="R7113856780a0458d"/>
+          <a:blip xmlns:r="http://schemas.openxmlformats.org/officeDocument/2006/relationships" xmlns:a="http://schemas.openxmlformats.org/drawingml/2006/main" r:embed="R71a51a6171c34e13"/>
           <a:stretch xmlns:a="http://schemas.openxmlformats.org/drawingml/2006/main">
             <a:fillRect l="0" t="0" r="0" b="0"/>
           </a:stretch>
@@ -11141,7 +11141,7 @@
           <p:nvPr/>
         </p:nvPicPr>
         <p:blipFill>
-          <a:blip xmlns:r="http://schemas.openxmlformats.org/officeDocument/2006/relationships" xmlns:a="http://schemas.openxmlformats.org/drawingml/2006/main" r:embed="R6cf336d19a4b472c"/>
+          <a:blip xmlns:r="http://schemas.openxmlformats.org/officeDocument/2006/relationships" xmlns:a="http://schemas.openxmlformats.org/drawingml/2006/main" r:embed="R2ed6ff1b499e4653"/>
           <a:stretch xmlns:a="http://schemas.openxmlformats.org/drawingml/2006/main">
             <a:fillRect l="0" t="0" r="0" b="0"/>
           </a:stretch>
@@ -11218,7 +11218,7 @@
           <p:nvPr/>
         </p:nvPicPr>
         <p:blipFill>
-          <a:blip xmlns:r="http://schemas.openxmlformats.org/officeDocument/2006/relationships" xmlns:a="http://schemas.openxmlformats.org/drawingml/2006/main" r:embed="Rf0659f2910a2441a"/>
+          <a:blip xmlns:r="http://schemas.openxmlformats.org/officeDocument/2006/relationships" xmlns:a="http://schemas.openxmlformats.org/drawingml/2006/main" r:embed="R6d0fe09e0fb04aa1"/>
           <a:stretch xmlns:a="http://schemas.openxmlformats.org/drawingml/2006/main">
             <a:fillRect l="0" t="0" r="0" b="0"/>
           </a:stretch>
@@ -11295,7 +11295,7 @@
           <p:nvPr/>
         </p:nvPicPr>
         <p:blipFill>
-          <a:blip xmlns:r="http://schemas.openxmlformats.org/officeDocument/2006/relationships" xmlns:a="http://schemas.openxmlformats.org/drawingml/2006/main" r:embed="R5b86fa9d23004311"/>
+          <a:blip xmlns:r="http://schemas.openxmlformats.org/officeDocument/2006/relationships" xmlns:a="http://schemas.openxmlformats.org/drawingml/2006/main" r:embed="R22823b9021e14b22"/>
           <a:stretch xmlns:a="http://schemas.openxmlformats.org/drawingml/2006/main">
             <a:fillRect l="0" t="0" r="0" b="0"/>
           </a:stretch>
@@ -11372,7 +11372,7 @@
           <p:nvPr/>
         </p:nvPicPr>
         <p:blipFill>
-          <a:blip xmlns:r="http://schemas.openxmlformats.org/officeDocument/2006/relationships" xmlns:a="http://schemas.openxmlformats.org/drawingml/2006/main" r:embed="Rc82ce00031fb485b"/>
+          <a:blip xmlns:r="http://schemas.openxmlformats.org/officeDocument/2006/relationships" xmlns:a="http://schemas.openxmlformats.org/drawingml/2006/main" r:embed="R692d0b3214a842e6"/>
           <a:stretch xmlns:a="http://schemas.openxmlformats.org/drawingml/2006/main">
             <a:fillRect l="0" t="0" r="0" b="0"/>
           </a:stretch>
@@ -11449,7 +11449,7 @@
           <p:nvPr/>
         </p:nvPicPr>
         <p:blipFill>
-          <a:blip xmlns:r="http://schemas.openxmlformats.org/officeDocument/2006/relationships" xmlns:a="http://schemas.openxmlformats.org/drawingml/2006/main" r:embed="R756d4f5f74b54d9c"/>
+          <a:blip xmlns:r="http://schemas.openxmlformats.org/officeDocument/2006/relationships" xmlns:a="http://schemas.openxmlformats.org/drawingml/2006/main" r:embed="R37cb361c0e1e4ede"/>
           <a:stretch xmlns:a="http://schemas.openxmlformats.org/drawingml/2006/main">
             <a:fillRect l="0" t="0" r="0" b="0"/>
           </a:stretch>
@@ -11526,7 +11526,7 @@
           <p:nvPr/>
         </p:nvPicPr>
         <p:blipFill>
-          <a:blip xmlns:r="http://schemas.openxmlformats.org/officeDocument/2006/relationships" xmlns:a="http://schemas.openxmlformats.org/drawingml/2006/main" r:embed="R2b631b764cd74ccb"/>
+          <a:blip xmlns:r="http://schemas.openxmlformats.org/officeDocument/2006/relationships" xmlns:a="http://schemas.openxmlformats.org/drawingml/2006/main" r:embed="R01fb99261ad347d8"/>
           <a:stretch xmlns:a="http://schemas.openxmlformats.org/drawingml/2006/main">
             <a:fillRect l="0" t="0" r="0" b="0"/>
           </a:stretch>
@@ -11816,7 +11816,7 @@
           <p:nvPr/>
         </p:nvPicPr>
         <p:blipFill>
-          <a:blip xmlns:r="http://schemas.openxmlformats.org/officeDocument/2006/relationships" xmlns:a="http://schemas.openxmlformats.org/drawingml/2006/main" r:embed="R5c3cdb9c326047e1"/>
+          <a:blip xmlns:r="http://schemas.openxmlformats.org/officeDocument/2006/relationships" xmlns:a="http://schemas.openxmlformats.org/drawingml/2006/main" r:embed="R4e6205ee872b4d01"/>
           <a:stretch xmlns:a="http://schemas.openxmlformats.org/drawingml/2006/main">
             <a:fillRect l="0" t="0" r="0" b="0"/>
           </a:stretch>
@@ -11999,7 +11999,7 @@
           <p:nvPr/>
         </p:nvPicPr>
         <p:blipFill>
-          <a:blip xmlns:r="http://schemas.openxmlformats.org/officeDocument/2006/relationships" xmlns:a="http://schemas.openxmlformats.org/drawingml/2006/main" r:embed="Rd5aea3573dfb4b51"/>
+          <a:blip xmlns:r="http://schemas.openxmlformats.org/officeDocument/2006/relationships" xmlns:a="http://schemas.openxmlformats.org/drawingml/2006/main" r:embed="R7ef63eda34774b49"/>
           <a:stretch xmlns:a="http://schemas.openxmlformats.org/drawingml/2006/main">
             <a:fillRect l="0" t="0" r="0" b="0"/>
           </a:stretch>
@@ -12023,7 +12023,7 @@
           <p:nvPr/>
         </p:nvPicPr>
         <p:blipFill>
-          <a:blip xmlns:r="http://schemas.openxmlformats.org/officeDocument/2006/relationships" xmlns:a="http://schemas.openxmlformats.org/drawingml/2006/main" r:embed="R3ec3c1f608c440db"/>
+          <a:blip xmlns:r="http://schemas.openxmlformats.org/officeDocument/2006/relationships" xmlns:a="http://schemas.openxmlformats.org/drawingml/2006/main" r:embed="R03559a305fd24410"/>
           <a:stretch xmlns:a="http://schemas.openxmlformats.org/drawingml/2006/main">
             <a:fillRect l="0" t="0" r="0" b="0"/>
           </a:stretch>
@@ -12949,7 +12949,7 @@
           <p:nvPr/>
         </p:nvPicPr>
         <p:blipFill>
-          <a:blip xmlns:r="http://schemas.openxmlformats.org/officeDocument/2006/relationships" xmlns:a="http://schemas.openxmlformats.org/drawingml/2006/main" r:embed="Racb8ae6bd8a34a2b"/>
+          <a:blip xmlns:r="http://schemas.openxmlformats.org/officeDocument/2006/relationships" xmlns:a="http://schemas.openxmlformats.org/drawingml/2006/main" r:embed="R458e19f0e3164aff"/>
           <a:stretch xmlns:a="http://schemas.openxmlformats.org/drawingml/2006/main">
             <a:fillRect l="0" t="0" r="0" b="0"/>
           </a:stretch>
@@ -12973,7 +12973,7 @@
           <p:nvPr/>
         </p:nvPicPr>
         <p:blipFill>
-          <a:blip xmlns:r="http://schemas.openxmlformats.org/officeDocument/2006/relationships" xmlns:a="http://schemas.openxmlformats.org/drawingml/2006/main" r:embed="R4c6f27b67c9e469d"/>
+          <a:blip xmlns:r="http://schemas.openxmlformats.org/officeDocument/2006/relationships" xmlns:a="http://schemas.openxmlformats.org/drawingml/2006/main" r:embed="Rc3c01a055b534f3c"/>
           <a:stretch xmlns:a="http://schemas.openxmlformats.org/drawingml/2006/main">
             <a:fillRect l="0" t="0" r="0" b="0"/>
           </a:stretch>
@@ -13209,7 +13209,7 @@
           <p:nvPr/>
         </p:nvPicPr>
         <p:blipFill>
-          <a:blip xmlns:r="http://schemas.openxmlformats.org/officeDocument/2006/relationships" xmlns:a="http://schemas.openxmlformats.org/drawingml/2006/main" r:embed="R5efdc22eda724aa1"/>
+          <a:blip xmlns:r="http://schemas.openxmlformats.org/officeDocument/2006/relationships" xmlns:a="http://schemas.openxmlformats.org/drawingml/2006/main" r:embed="R42f6493cb05e4ebc"/>
           <a:stretch xmlns:a="http://schemas.openxmlformats.org/drawingml/2006/main">
             <a:fillRect l="0" t="0" r="0" b="0"/>
           </a:stretch>
@@ -13286,7 +13286,7 @@
           <p:nvPr/>
         </p:nvPicPr>
         <p:blipFill>
-          <a:blip xmlns:r="http://schemas.openxmlformats.org/officeDocument/2006/relationships" xmlns:a="http://schemas.openxmlformats.org/drawingml/2006/main" r:embed="R215a21bfbbfe41bd"/>
+          <a:blip xmlns:r="http://schemas.openxmlformats.org/officeDocument/2006/relationships" xmlns:a="http://schemas.openxmlformats.org/drawingml/2006/main" r:embed="R94aba85c9c4e4a3a"/>
           <a:stretch xmlns:a="http://schemas.openxmlformats.org/drawingml/2006/main">
             <a:fillRect l="0" t="0" r="0" b="0"/>
           </a:stretch>
@@ -13363,7 +13363,7 @@
           <p:nvPr/>
         </p:nvPicPr>
         <p:blipFill>
-          <a:blip xmlns:r="http://schemas.openxmlformats.org/officeDocument/2006/relationships" xmlns:a="http://schemas.openxmlformats.org/drawingml/2006/main" r:embed="R6a812ffa5d9549e1"/>
+          <a:blip xmlns:r="http://schemas.openxmlformats.org/officeDocument/2006/relationships" xmlns:a="http://schemas.openxmlformats.org/drawingml/2006/main" r:embed="R6ff8f5d92e7446ab"/>
           <a:stretch xmlns:a="http://schemas.openxmlformats.org/drawingml/2006/main">
             <a:fillRect l="0" t="0" r="0" b="0"/>
           </a:stretch>
@@ -13440,7 +13440,7 @@
           <p:nvPr/>
         </p:nvPicPr>
         <p:blipFill>
-          <a:blip xmlns:r="http://schemas.openxmlformats.org/officeDocument/2006/relationships" xmlns:a="http://schemas.openxmlformats.org/drawingml/2006/main" r:embed="Ra8f1569a3b834fc6"/>
+          <a:blip xmlns:r="http://schemas.openxmlformats.org/officeDocument/2006/relationships" xmlns:a="http://schemas.openxmlformats.org/drawingml/2006/main" r:embed="R34614f9158374c7a"/>
           <a:stretch xmlns:a="http://schemas.openxmlformats.org/drawingml/2006/main">
             <a:fillRect l="0" t="0" r="0" b="0"/>
           </a:stretch>
@@ -13517,7 +13517,7 @@
           <p:nvPr/>
         </p:nvPicPr>
         <p:blipFill>
-          <a:blip xmlns:r="http://schemas.openxmlformats.org/officeDocument/2006/relationships" xmlns:a="http://schemas.openxmlformats.org/drawingml/2006/main" r:embed="Rd312361a35df4a2b"/>
+          <a:blip xmlns:r="http://schemas.openxmlformats.org/officeDocument/2006/relationships" xmlns:a="http://schemas.openxmlformats.org/drawingml/2006/main" r:embed="R1d320990476146cd"/>
           <a:stretch xmlns:a="http://schemas.openxmlformats.org/drawingml/2006/main">
             <a:fillRect l="0" t="0" r="0" b="0"/>
           </a:stretch>
@@ -13594,7 +13594,7 @@
           <p:nvPr/>
         </p:nvPicPr>
         <p:blipFill>
-          <a:blip xmlns:r="http://schemas.openxmlformats.org/officeDocument/2006/relationships" xmlns:a="http://schemas.openxmlformats.org/drawingml/2006/main" r:embed="R90d9d8893d824ca3"/>
+          <a:blip xmlns:r="http://schemas.openxmlformats.org/officeDocument/2006/relationships" xmlns:a="http://schemas.openxmlformats.org/drawingml/2006/main" r:embed="R9dc75f3305c94cf3"/>
           <a:stretch xmlns:a="http://schemas.openxmlformats.org/drawingml/2006/main">
             <a:fillRect l="0" t="0" r="0" b="0"/>
           </a:stretch>
@@ -13671,7 +13671,7 @@
           <p:nvPr/>
         </p:nvPicPr>
         <p:blipFill>
-          <a:blip xmlns:r="http://schemas.openxmlformats.org/officeDocument/2006/relationships" xmlns:a="http://schemas.openxmlformats.org/drawingml/2006/main" r:embed="Rb0ad695df36342e1"/>
+          <a:blip xmlns:r="http://schemas.openxmlformats.org/officeDocument/2006/relationships" xmlns:a="http://schemas.openxmlformats.org/drawingml/2006/main" r:embed="Rae9ca93c77a740dc"/>
           <a:stretch xmlns:a="http://schemas.openxmlformats.org/drawingml/2006/main">
             <a:fillRect l="0" t="0" r="0" b="0"/>
           </a:stretch>
@@ -13961,7 +13961,7 @@
           <p:nvPr/>
         </p:nvPicPr>
         <p:blipFill>
-          <a:blip xmlns:r="http://schemas.openxmlformats.org/officeDocument/2006/relationships" xmlns:a="http://schemas.openxmlformats.org/drawingml/2006/main" r:embed="R8cac066a237b4741"/>
+          <a:blip xmlns:r="http://schemas.openxmlformats.org/officeDocument/2006/relationships" xmlns:a="http://schemas.openxmlformats.org/drawingml/2006/main" r:embed="Reacb6f1486344fb0"/>
           <a:stretch xmlns:a="http://schemas.openxmlformats.org/drawingml/2006/main">
             <a:fillRect l="0" t="0" r="0" b="0"/>
           </a:stretch>
@@ -14144,7 +14144,7 @@
           <p:nvPr/>
         </p:nvPicPr>
         <p:blipFill>
-          <a:blip xmlns:r="http://schemas.openxmlformats.org/officeDocument/2006/relationships" xmlns:a="http://schemas.openxmlformats.org/drawingml/2006/main" r:embed="R44498321e0234b58"/>
+          <a:blip xmlns:r="http://schemas.openxmlformats.org/officeDocument/2006/relationships" xmlns:a="http://schemas.openxmlformats.org/drawingml/2006/main" r:embed="R8f5b55ba79e6416b"/>
           <a:stretch xmlns:a="http://schemas.openxmlformats.org/drawingml/2006/main">
             <a:fillRect l="0" t="0" r="0" b="0"/>
           </a:stretch>
@@ -14168,7 +14168,7 @@
           <p:nvPr/>
         </p:nvPicPr>
         <p:blipFill>
-          <a:blip xmlns:r="http://schemas.openxmlformats.org/officeDocument/2006/relationships" xmlns:a="http://schemas.openxmlformats.org/drawingml/2006/main" r:embed="Re220e11fc631473a"/>
+          <a:blip xmlns:r="http://schemas.openxmlformats.org/officeDocument/2006/relationships" xmlns:a="http://schemas.openxmlformats.org/drawingml/2006/main" r:embed="R20f3c6623dab43ff"/>
           <a:stretch xmlns:a="http://schemas.openxmlformats.org/drawingml/2006/main">
             <a:fillRect l="0" t="0" r="0" b="0"/>
           </a:stretch>
@@ -14433,7 +14433,7 @@
           <p:nvPr/>
         </p:nvPicPr>
         <p:blipFill>
-          <a:blip xmlns:r="http://schemas.openxmlformats.org/officeDocument/2006/relationships" xmlns:a="http://schemas.openxmlformats.org/drawingml/2006/main" r:embed="R660cd9f9c7824519"/>
+          <a:blip xmlns:r="http://schemas.openxmlformats.org/officeDocument/2006/relationships" xmlns:a="http://schemas.openxmlformats.org/drawingml/2006/main" r:embed="R984f1a6377c94a6d"/>
           <a:stretch xmlns:a="http://schemas.openxmlformats.org/drawingml/2006/main">
             <a:fillRect l="0" t="0" r="0" b="0"/>
           </a:stretch>
@@ -14503,7 +14503,7 @@
           <p:nvPr/>
         </p:nvPicPr>
         <p:blipFill>
-          <a:blip xmlns:r="http://schemas.openxmlformats.org/officeDocument/2006/relationships" xmlns:a="http://schemas.openxmlformats.org/drawingml/2006/main" r:embed="R81e3738d9bdf49c7"/>
+          <a:blip xmlns:r="http://schemas.openxmlformats.org/officeDocument/2006/relationships" xmlns:a="http://schemas.openxmlformats.org/drawingml/2006/main" r:embed="R6feb6125939b4297"/>
           <a:stretch xmlns:a="http://schemas.openxmlformats.org/drawingml/2006/main">
             <a:fillRect l="0" t="0" r="0" b="0"/>
           </a:stretch>
@@ -14573,7 +14573,7 @@
           <p:nvPr/>
         </p:nvPicPr>
         <p:blipFill>
-          <a:blip xmlns:r="http://schemas.openxmlformats.org/officeDocument/2006/relationships" xmlns:a="http://schemas.openxmlformats.org/drawingml/2006/main" r:embed="R8220e0a2699641b3"/>
+          <a:blip xmlns:r="http://schemas.openxmlformats.org/officeDocument/2006/relationships" xmlns:a="http://schemas.openxmlformats.org/drawingml/2006/main" r:embed="R6a74434eb0d24a03"/>
           <a:stretch xmlns:a="http://schemas.openxmlformats.org/drawingml/2006/main">
             <a:fillRect l="0" t="0" r="0" b="0"/>
           </a:stretch>
@@ -14643,7 +14643,7 @@
           <p:nvPr/>
         </p:nvPicPr>
         <p:blipFill>
-          <a:blip xmlns:r="http://schemas.openxmlformats.org/officeDocument/2006/relationships" xmlns:a="http://schemas.openxmlformats.org/drawingml/2006/main" r:embed="R1364d9a4f1ec44bc"/>
+          <a:blip xmlns:r="http://schemas.openxmlformats.org/officeDocument/2006/relationships" xmlns:a="http://schemas.openxmlformats.org/drawingml/2006/main" r:embed="R68d67f8784864b0e"/>
           <a:stretch xmlns:a="http://schemas.openxmlformats.org/drawingml/2006/main">
             <a:fillRect l="0" t="0" r="0" b="0"/>
           </a:stretch>
@@ -14713,7 +14713,7 @@
           <p:nvPr/>
         </p:nvPicPr>
         <p:blipFill>
-          <a:blip xmlns:r="http://schemas.openxmlformats.org/officeDocument/2006/relationships" xmlns:a="http://schemas.openxmlformats.org/drawingml/2006/main" r:embed="Rec62dc6d94fe46e4"/>
+          <a:blip xmlns:r="http://schemas.openxmlformats.org/officeDocument/2006/relationships" xmlns:a="http://schemas.openxmlformats.org/drawingml/2006/main" r:embed="R30c69fad3e044e6b"/>
           <a:stretch xmlns:a="http://schemas.openxmlformats.org/drawingml/2006/main">
             <a:fillRect l="0" t="0" r="0" b="0"/>
           </a:stretch>
@@ -14783,7 +14783,7 @@
           <p:nvPr/>
         </p:nvPicPr>
         <p:blipFill>
-          <a:blip xmlns:r="http://schemas.openxmlformats.org/officeDocument/2006/relationships" xmlns:a="http://schemas.openxmlformats.org/drawingml/2006/main" r:embed="R177508ff3a9048fe"/>
+          <a:blip xmlns:r="http://schemas.openxmlformats.org/officeDocument/2006/relationships" xmlns:a="http://schemas.openxmlformats.org/drawingml/2006/main" r:embed="Ra29816d0da624c0f"/>
           <a:stretch xmlns:a="http://schemas.openxmlformats.org/drawingml/2006/main">
             <a:fillRect l="0" t="0" r="0" b="0"/>
           </a:stretch>
@@ -14853,7 +14853,7 @@
           <p:nvPr/>
         </p:nvPicPr>
         <p:blipFill>
-          <a:blip xmlns:r="http://schemas.openxmlformats.org/officeDocument/2006/relationships" xmlns:a="http://schemas.openxmlformats.org/drawingml/2006/main" r:embed="R11dedc0c8d3d402c"/>
+          <a:blip xmlns:r="http://schemas.openxmlformats.org/officeDocument/2006/relationships" xmlns:a="http://schemas.openxmlformats.org/drawingml/2006/main" r:embed="Rd3e546fd2f624c69"/>
           <a:stretch xmlns:a="http://schemas.openxmlformats.org/drawingml/2006/main">
             <a:fillRect l="0" t="0" r="0" b="0"/>
           </a:stretch>
@@ -14992,7 +14992,7 @@
                 <a:ea typeface="Calibri"/>
                 <a:cs typeface="Calibri"/>
               </a:rPr>
-              <a:t>BUKTI YANG DIKUMPULKAN</a:t>
+              <a:t>PROYEK KELOMPOK</a:t>
             </a:r>
           </a:p>
           <a:p xmlns:a="http://schemas.openxmlformats.org/drawingml/2006/main">
@@ -15021,7 +15021,7 @@
                 <a:ea typeface="Calibri"/>
                 <a:cs typeface="Calibri"/>
               </a:rPr>
-              <a:t>Hasil mesin sendiri</a:t>
+              <a:t>Tim 3 orang</a:t>
             </a:r>
             <a:endParaRPr sz="1100"/>
           </a:p>
@@ -15070,7 +15070,7 @@
                 <a:ea typeface="Calibri"/>
                 <a:cs typeface="Calibri"/>
               </a:rPr>
-              <a:t>1. DB dan hasil ingest</a:t>
+              <a:t>RAG memberi jawaban bersumber bila relevan</a:t>
             </a:r>
           </a:p>
           <a:p xmlns:a="http://schemas.openxmlformats.org/drawingml/2006/main">
@@ -15089,7 +15089,7 @@
                 <a:ea typeface="Calibri"/>
                 <a:cs typeface="Calibri"/>
               </a:rPr>
-              <a:t>2. Top-K, jarak, dan sitasi [S1]</a:t>
+              <a:t>Uji top-K, sitasi, dan latensi</a:t>
             </a:r>
           </a:p>
           <a:p xmlns:a="http://schemas.openxmlformats.org/drawingml/2006/main">
@@ -15108,7 +15108,7 @@
                 <a:ea typeface="Calibri"/>
                 <a:cs typeface="Calibri"/>
               </a:rPr>
-              <a:t>3. Chat web/API dan dokumen baru</a:t>
+              <a:t>Simpan bukti bila berguna</a:t>
             </a:r>
           </a:p>
           <a:p xmlns:a="http://schemas.openxmlformats.org/drawingml/2006/main">
@@ -15127,7 +15127,7 @@
                 <a:ea typeface="Calibri"/>
                 <a:cs typeface="Calibri"/>
               </a:rPr>
-              <a:t>4. p50/p95 dan commit aman</a:t>
+              <a:t>Minggu 7 dan 14; tanpa nilai Lab 11</a:t>
             </a:r>
             <a:endParaRPr sz="1700"/>
           </a:p>
@@ -15385,7 +15385,7 @@
           <p:nvPr/>
         </p:nvPicPr>
         <p:blipFill>
-          <a:blip xmlns:r="http://schemas.openxmlformats.org/officeDocument/2006/relationships" xmlns:a="http://schemas.openxmlformats.org/drawingml/2006/main" r:embed="Rb128ac25bc624fcb"/>
+          <a:blip xmlns:r="http://schemas.openxmlformats.org/officeDocument/2006/relationships" xmlns:a="http://schemas.openxmlformats.org/drawingml/2006/main" r:embed="Reea39472465d4ea5"/>
           <a:stretch xmlns:a="http://schemas.openxmlformats.org/drawingml/2006/main">
             <a:fillRect l="0" t="0" r="0" b="0"/>
           </a:stretch>
@@ -15409,7 +15409,7 @@
           <p:nvPr/>
         </p:nvPicPr>
         <p:blipFill>
-          <a:blip xmlns:r="http://schemas.openxmlformats.org/officeDocument/2006/relationships" xmlns:a="http://schemas.openxmlformats.org/drawingml/2006/main" r:embed="Rf2f194f42e7a4141"/>
+          <a:blip xmlns:r="http://schemas.openxmlformats.org/officeDocument/2006/relationships" xmlns:a="http://schemas.openxmlformats.org/drawingml/2006/main" r:embed="Reba73944c63945f8"/>
           <a:stretch xmlns:a="http://schemas.openxmlformats.org/drawingml/2006/main">
             <a:fillRect l="0" t="0" r="0" b="0"/>
           </a:stretch>
@@ -16331,7 +16331,7 @@
           <p:nvPr/>
         </p:nvPicPr>
         <p:blipFill>
-          <a:blip xmlns:r="http://schemas.openxmlformats.org/officeDocument/2006/relationships" xmlns:a="http://schemas.openxmlformats.org/drawingml/2006/main" r:embed="R720b58fc08114f8d"/>
+          <a:blip xmlns:r="http://schemas.openxmlformats.org/officeDocument/2006/relationships" xmlns:a="http://schemas.openxmlformats.org/drawingml/2006/main" r:embed="Rc1368ad6c1334f26"/>
           <a:stretch xmlns:a="http://schemas.openxmlformats.org/drawingml/2006/main">
             <a:fillRect l="0" t="0" r="0" b="0"/>
           </a:stretch>
@@ -16355,7 +16355,7 @@
           <p:nvPr/>
         </p:nvPicPr>
         <p:blipFill>
-          <a:blip xmlns:r="http://schemas.openxmlformats.org/officeDocument/2006/relationships" xmlns:a="http://schemas.openxmlformats.org/drawingml/2006/main" r:embed="R1f54dd849c844493"/>
+          <a:blip xmlns:r="http://schemas.openxmlformats.org/officeDocument/2006/relationships" xmlns:a="http://schemas.openxmlformats.org/drawingml/2006/main" r:embed="R5e98dd3afdd84be2"/>
           <a:stretch xmlns:a="http://schemas.openxmlformats.org/drawingml/2006/main">
             <a:fillRect l="0" t="0" r="0" b="0"/>
           </a:stretch>
@@ -16591,7 +16591,7 @@
           <p:nvPr/>
         </p:nvPicPr>
         <p:blipFill>
-          <a:blip xmlns:r="http://schemas.openxmlformats.org/officeDocument/2006/relationships" xmlns:a="http://schemas.openxmlformats.org/drawingml/2006/main" r:embed="Rcf437929f4d2465c"/>
+          <a:blip xmlns:r="http://schemas.openxmlformats.org/officeDocument/2006/relationships" xmlns:a="http://schemas.openxmlformats.org/drawingml/2006/main" r:embed="Rd72b27ddb5894572"/>
           <a:stretch xmlns:a="http://schemas.openxmlformats.org/drawingml/2006/main">
             <a:fillRect l="0" t="0" r="0" b="0"/>
           </a:stretch>
@@ -16668,7 +16668,7 @@
           <p:nvPr/>
         </p:nvPicPr>
         <p:blipFill>
-          <a:blip xmlns:r="http://schemas.openxmlformats.org/officeDocument/2006/relationships" xmlns:a="http://schemas.openxmlformats.org/drawingml/2006/main" r:embed="Rc8aacba4baea4a14"/>
+          <a:blip xmlns:r="http://schemas.openxmlformats.org/officeDocument/2006/relationships" xmlns:a="http://schemas.openxmlformats.org/drawingml/2006/main" r:embed="Re70d3f4daccf4813"/>
           <a:stretch xmlns:a="http://schemas.openxmlformats.org/drawingml/2006/main">
             <a:fillRect l="0" t="0" r="0" b="0"/>
           </a:stretch>
@@ -16745,7 +16745,7 @@
           <p:nvPr/>
         </p:nvPicPr>
         <p:blipFill>
-          <a:blip xmlns:r="http://schemas.openxmlformats.org/officeDocument/2006/relationships" xmlns:a="http://schemas.openxmlformats.org/drawingml/2006/main" r:embed="R975d762d3cf34617"/>
+          <a:blip xmlns:r="http://schemas.openxmlformats.org/officeDocument/2006/relationships" xmlns:a="http://schemas.openxmlformats.org/drawingml/2006/main" r:embed="Rb2dfc5f4e5684752"/>
           <a:stretch xmlns:a="http://schemas.openxmlformats.org/drawingml/2006/main">
             <a:fillRect l="0" t="0" r="0" b="0"/>
           </a:stretch>
@@ -16822,7 +16822,7 @@
           <p:nvPr/>
         </p:nvPicPr>
         <p:blipFill>
-          <a:blip xmlns:r="http://schemas.openxmlformats.org/officeDocument/2006/relationships" xmlns:a="http://schemas.openxmlformats.org/drawingml/2006/main" r:embed="Ra16ab4464f594fe9"/>
+          <a:blip xmlns:r="http://schemas.openxmlformats.org/officeDocument/2006/relationships" xmlns:a="http://schemas.openxmlformats.org/drawingml/2006/main" r:embed="Rcf89ac638cf345f3"/>
           <a:stretch xmlns:a="http://schemas.openxmlformats.org/drawingml/2006/main">
             <a:fillRect l="0" t="0" r="0" b="0"/>
           </a:stretch>
@@ -16899,7 +16899,7 @@
           <p:nvPr/>
         </p:nvPicPr>
         <p:blipFill>
-          <a:blip xmlns:r="http://schemas.openxmlformats.org/officeDocument/2006/relationships" xmlns:a="http://schemas.openxmlformats.org/drawingml/2006/main" r:embed="R81e450eb0bad4284"/>
+          <a:blip xmlns:r="http://schemas.openxmlformats.org/officeDocument/2006/relationships" xmlns:a="http://schemas.openxmlformats.org/drawingml/2006/main" r:embed="Reebe0f73dc3a49ff"/>
           <a:stretch xmlns:a="http://schemas.openxmlformats.org/drawingml/2006/main">
             <a:fillRect l="0" t="0" r="0" b="0"/>
           </a:stretch>
@@ -16976,7 +16976,7 @@
           <p:nvPr/>
         </p:nvPicPr>
         <p:blipFill>
-          <a:blip xmlns:r="http://schemas.openxmlformats.org/officeDocument/2006/relationships" xmlns:a="http://schemas.openxmlformats.org/drawingml/2006/main" r:embed="R53535563056e4621"/>
+          <a:blip xmlns:r="http://schemas.openxmlformats.org/officeDocument/2006/relationships" xmlns:a="http://schemas.openxmlformats.org/drawingml/2006/main" r:embed="R8b539e0142944f77"/>
           <a:stretch xmlns:a="http://schemas.openxmlformats.org/drawingml/2006/main">
             <a:fillRect l="0" t="0" r="0" b="0"/>
           </a:stretch>
@@ -17053,7 +17053,7 @@
           <p:nvPr/>
         </p:nvPicPr>
         <p:blipFill>
-          <a:blip xmlns:r="http://schemas.openxmlformats.org/officeDocument/2006/relationships" xmlns:a="http://schemas.openxmlformats.org/drawingml/2006/main" r:embed="R9da5f66db3254474"/>
+          <a:blip xmlns:r="http://schemas.openxmlformats.org/officeDocument/2006/relationships" xmlns:a="http://schemas.openxmlformats.org/drawingml/2006/main" r:embed="Rdb20efce4ec04d9a"/>
           <a:stretch xmlns:a="http://schemas.openxmlformats.org/drawingml/2006/main">
             <a:fillRect l="0" t="0" r="0" b="0"/>
           </a:stretch>
@@ -17343,7 +17343,7 @@
           <p:nvPr/>
         </p:nvPicPr>
         <p:blipFill>
-          <a:blip xmlns:r="http://schemas.openxmlformats.org/officeDocument/2006/relationships" xmlns:a="http://schemas.openxmlformats.org/drawingml/2006/main" r:embed="Rc60c9a2d43174e7c"/>
+          <a:blip xmlns:r="http://schemas.openxmlformats.org/officeDocument/2006/relationships" xmlns:a="http://schemas.openxmlformats.org/drawingml/2006/main" r:embed="R44139d5560144512"/>
           <a:stretch xmlns:a="http://schemas.openxmlformats.org/drawingml/2006/main">
             <a:fillRect l="0" t="0" r="0" b="0"/>
           </a:stretch>
@@ -17526,7 +17526,7 @@
           <p:nvPr/>
         </p:nvPicPr>
         <p:blipFill>
-          <a:blip xmlns:r="http://schemas.openxmlformats.org/officeDocument/2006/relationships" xmlns:a="http://schemas.openxmlformats.org/drawingml/2006/main" r:embed="Rec143b1826394122"/>
+          <a:blip xmlns:r="http://schemas.openxmlformats.org/officeDocument/2006/relationships" xmlns:a="http://schemas.openxmlformats.org/drawingml/2006/main" r:embed="R3c2f4c201f3740ad"/>
           <a:stretch xmlns:a="http://schemas.openxmlformats.org/drawingml/2006/main">
             <a:fillRect l="0" t="0" r="0" b="0"/>
           </a:stretch>
@@ -17550,7 +17550,7 @@
           <p:nvPr/>
         </p:nvPicPr>
         <p:blipFill>
-          <a:blip xmlns:r="http://schemas.openxmlformats.org/officeDocument/2006/relationships" xmlns:a="http://schemas.openxmlformats.org/drawingml/2006/main" r:embed="R60b2e15514d24e1f"/>
+          <a:blip xmlns:r="http://schemas.openxmlformats.org/officeDocument/2006/relationships" xmlns:a="http://schemas.openxmlformats.org/drawingml/2006/main" r:embed="Re03d7eb26b8344bd"/>
           <a:stretch xmlns:a="http://schemas.openxmlformats.org/drawingml/2006/main">
             <a:fillRect l="0" t="0" r="0" b="0"/>
           </a:stretch>
@@ -18478,7 +18478,7 @@
           <p:nvPr/>
         </p:nvPicPr>
         <p:blipFill>
-          <a:blip xmlns:r="http://schemas.openxmlformats.org/officeDocument/2006/relationships" xmlns:a="http://schemas.openxmlformats.org/drawingml/2006/main" r:embed="Rc396e1ad12634d63"/>
+          <a:blip xmlns:r="http://schemas.openxmlformats.org/officeDocument/2006/relationships" xmlns:a="http://schemas.openxmlformats.org/drawingml/2006/main" r:embed="Red7be3415a6349ca"/>
           <a:stretch xmlns:a="http://schemas.openxmlformats.org/drawingml/2006/main">
             <a:fillRect l="0" t="0" r="0" b="0"/>
           </a:stretch>
@@ -18502,7 +18502,7 @@
           <p:nvPr/>
         </p:nvPicPr>
         <p:blipFill>
-          <a:blip xmlns:r="http://schemas.openxmlformats.org/officeDocument/2006/relationships" xmlns:a="http://schemas.openxmlformats.org/drawingml/2006/main" r:embed="R66183b66f9eb41a6"/>
+          <a:blip xmlns:r="http://schemas.openxmlformats.org/officeDocument/2006/relationships" xmlns:a="http://schemas.openxmlformats.org/drawingml/2006/main" r:embed="Rec37b8143558497c"/>
           <a:stretch xmlns:a="http://schemas.openxmlformats.org/drawingml/2006/main">
             <a:fillRect l="0" t="0" r="0" b="0"/>
           </a:stretch>
@@ -19429,7 +19429,7 @@
           <p:nvPr/>
         </p:nvPicPr>
         <p:blipFill>
-          <a:blip xmlns:r="http://schemas.openxmlformats.org/officeDocument/2006/relationships" xmlns:a="http://schemas.openxmlformats.org/drawingml/2006/main" r:embed="R639a1fd4fae6470d"/>
+          <a:blip xmlns:r="http://schemas.openxmlformats.org/officeDocument/2006/relationships" xmlns:a="http://schemas.openxmlformats.org/drawingml/2006/main" r:embed="Rd12342453b444cee"/>
           <a:stretch xmlns:a="http://schemas.openxmlformats.org/drawingml/2006/main">
             <a:fillRect l="0" t="0" r="0" b="0"/>
           </a:stretch>
@@ -19453,7 +19453,7 @@
           <p:nvPr/>
         </p:nvPicPr>
         <p:blipFill>
-          <a:blip xmlns:r="http://schemas.openxmlformats.org/officeDocument/2006/relationships" xmlns:a="http://schemas.openxmlformats.org/drawingml/2006/main" r:embed="R1b74d4da06ba4770"/>
+          <a:blip xmlns:r="http://schemas.openxmlformats.org/officeDocument/2006/relationships" xmlns:a="http://schemas.openxmlformats.org/drawingml/2006/main" r:embed="R504ca6b368ff45cd"/>
           <a:stretch xmlns:a="http://schemas.openxmlformats.org/drawingml/2006/main">
             <a:fillRect l="0" t="0" r="0" b="0"/>
           </a:stretch>
@@ -19689,7 +19689,7 @@
           <p:nvPr/>
         </p:nvPicPr>
         <p:blipFill>
-          <a:blip xmlns:r="http://schemas.openxmlformats.org/officeDocument/2006/relationships" xmlns:a="http://schemas.openxmlformats.org/drawingml/2006/main" r:embed="R761f156a69f04273"/>
+          <a:blip xmlns:r="http://schemas.openxmlformats.org/officeDocument/2006/relationships" xmlns:a="http://schemas.openxmlformats.org/drawingml/2006/main" r:embed="R8acd6b2c73cd43dd"/>
           <a:stretch xmlns:a="http://schemas.openxmlformats.org/drawingml/2006/main">
             <a:fillRect l="0" t="0" r="0" b="0"/>
           </a:stretch>
@@ -19766,7 +19766,7 @@
           <p:nvPr/>
         </p:nvPicPr>
         <p:blipFill>
-          <a:blip xmlns:r="http://schemas.openxmlformats.org/officeDocument/2006/relationships" xmlns:a="http://schemas.openxmlformats.org/drawingml/2006/main" r:embed="Rfe7504f7e5cc4fa5"/>
+          <a:blip xmlns:r="http://schemas.openxmlformats.org/officeDocument/2006/relationships" xmlns:a="http://schemas.openxmlformats.org/drawingml/2006/main" r:embed="R658f42cdb5f84d60"/>
           <a:stretch xmlns:a="http://schemas.openxmlformats.org/drawingml/2006/main">
             <a:fillRect l="0" t="0" r="0" b="0"/>
           </a:stretch>
@@ -19843,7 +19843,7 @@
           <p:nvPr/>
         </p:nvPicPr>
         <p:blipFill>
-          <a:blip xmlns:r="http://schemas.openxmlformats.org/officeDocument/2006/relationships" xmlns:a="http://schemas.openxmlformats.org/drawingml/2006/main" r:embed="R75381f65c9d044ff"/>
+          <a:blip xmlns:r="http://schemas.openxmlformats.org/officeDocument/2006/relationships" xmlns:a="http://schemas.openxmlformats.org/drawingml/2006/main" r:embed="R2c99ad1cd44e409d"/>
           <a:stretch xmlns:a="http://schemas.openxmlformats.org/drawingml/2006/main">
             <a:fillRect l="0" t="0" r="0" b="0"/>
           </a:stretch>
@@ -19920,7 +19920,7 @@
           <p:nvPr/>
         </p:nvPicPr>
         <p:blipFill>
-          <a:blip xmlns:r="http://schemas.openxmlformats.org/officeDocument/2006/relationships" xmlns:a="http://schemas.openxmlformats.org/drawingml/2006/main" r:embed="R968d4918130d4c27"/>
+          <a:blip xmlns:r="http://schemas.openxmlformats.org/officeDocument/2006/relationships" xmlns:a="http://schemas.openxmlformats.org/drawingml/2006/main" r:embed="R11ac630a41b74049"/>
           <a:stretch xmlns:a="http://schemas.openxmlformats.org/drawingml/2006/main">
             <a:fillRect l="0" t="0" r="0" b="0"/>
           </a:stretch>
@@ -19997,7 +19997,7 @@
           <p:nvPr/>
         </p:nvPicPr>
         <p:blipFill>
-          <a:blip xmlns:r="http://schemas.openxmlformats.org/officeDocument/2006/relationships" xmlns:a="http://schemas.openxmlformats.org/drawingml/2006/main" r:embed="Rb93cd3e7b50946b5"/>
+          <a:blip xmlns:r="http://schemas.openxmlformats.org/officeDocument/2006/relationships" xmlns:a="http://schemas.openxmlformats.org/drawingml/2006/main" r:embed="R712d5bfc44a7403c"/>
           <a:stretch xmlns:a="http://schemas.openxmlformats.org/drawingml/2006/main">
             <a:fillRect l="0" t="0" r="0" b="0"/>
           </a:stretch>
@@ -20074,7 +20074,7 @@
           <p:nvPr/>
         </p:nvPicPr>
         <p:blipFill>
-          <a:blip xmlns:r="http://schemas.openxmlformats.org/officeDocument/2006/relationships" xmlns:a="http://schemas.openxmlformats.org/drawingml/2006/main" r:embed="R7d34582ce190479b"/>
+          <a:blip xmlns:r="http://schemas.openxmlformats.org/officeDocument/2006/relationships" xmlns:a="http://schemas.openxmlformats.org/drawingml/2006/main" r:embed="Re460573256174b8a"/>
           <a:stretch xmlns:a="http://schemas.openxmlformats.org/drawingml/2006/main">
             <a:fillRect l="0" t="0" r="0" b="0"/>
           </a:stretch>
@@ -20151,7 +20151,7 @@
           <p:nvPr/>
         </p:nvPicPr>
         <p:blipFill>
-          <a:blip xmlns:r="http://schemas.openxmlformats.org/officeDocument/2006/relationships" xmlns:a="http://schemas.openxmlformats.org/drawingml/2006/main" r:embed="R393d0c1f614b4e29"/>
+          <a:blip xmlns:r="http://schemas.openxmlformats.org/officeDocument/2006/relationships" xmlns:a="http://schemas.openxmlformats.org/drawingml/2006/main" r:embed="R2c986c7b829049a6"/>
           <a:stretch xmlns:a="http://schemas.openxmlformats.org/drawingml/2006/main">
             <a:fillRect l="0" t="0" r="0" b="0"/>
           </a:stretch>
@@ -20441,7 +20441,7 @@
           <p:nvPr/>
         </p:nvPicPr>
         <p:blipFill>
-          <a:blip xmlns:r="http://schemas.openxmlformats.org/officeDocument/2006/relationships" xmlns:a="http://schemas.openxmlformats.org/drawingml/2006/main" r:embed="Rf4cb896573f24c75"/>
+          <a:blip xmlns:r="http://schemas.openxmlformats.org/officeDocument/2006/relationships" xmlns:a="http://schemas.openxmlformats.org/drawingml/2006/main" r:embed="R24c15452b060437d"/>
           <a:stretch xmlns:a="http://schemas.openxmlformats.org/drawingml/2006/main">
             <a:fillRect l="0" t="0" r="0" b="0"/>
           </a:stretch>
@@ -20624,7 +20624,7 @@
           <p:nvPr/>
         </p:nvPicPr>
         <p:blipFill>
-          <a:blip xmlns:r="http://schemas.openxmlformats.org/officeDocument/2006/relationships" xmlns:a="http://schemas.openxmlformats.org/drawingml/2006/main" r:embed="R4729045ee01c4771"/>
+          <a:blip xmlns:r="http://schemas.openxmlformats.org/officeDocument/2006/relationships" xmlns:a="http://schemas.openxmlformats.org/drawingml/2006/main" r:embed="Rbc8871a0f118459d"/>
           <a:stretch xmlns:a="http://schemas.openxmlformats.org/drawingml/2006/main">
             <a:fillRect l="0" t="0" r="0" b="0"/>
           </a:stretch>
@@ -20648,7 +20648,7 @@
           <p:nvPr/>
         </p:nvPicPr>
         <p:blipFill>
-          <a:blip xmlns:r="http://schemas.openxmlformats.org/officeDocument/2006/relationships" xmlns:a="http://schemas.openxmlformats.org/drawingml/2006/main" r:embed="Rf18228aead874b3a"/>
+          <a:blip xmlns:r="http://schemas.openxmlformats.org/officeDocument/2006/relationships" xmlns:a="http://schemas.openxmlformats.org/drawingml/2006/main" r:embed="R1c00d6d3dafb43df"/>
           <a:stretch xmlns:a="http://schemas.openxmlformats.org/drawingml/2006/main">
             <a:fillRect l="0" t="0" r="0" b="0"/>
           </a:stretch>
@@ -20884,7 +20884,7 @@
           <p:nvPr/>
         </p:nvPicPr>
         <p:blipFill>
-          <a:blip xmlns:r="http://schemas.openxmlformats.org/officeDocument/2006/relationships" xmlns:a="http://schemas.openxmlformats.org/drawingml/2006/main" r:embed="R6562fd1b4f8541b3"/>
+          <a:blip xmlns:r="http://schemas.openxmlformats.org/officeDocument/2006/relationships" xmlns:a="http://schemas.openxmlformats.org/drawingml/2006/main" r:embed="R829a1b0dc14640fa"/>
           <a:stretch xmlns:a="http://schemas.openxmlformats.org/drawingml/2006/main">
             <a:fillRect l="0" t="0" r="0" b="0"/>
           </a:stretch>
@@ -20961,7 +20961,7 @@
           <p:nvPr/>
         </p:nvPicPr>
         <p:blipFill>
-          <a:blip xmlns:r="http://schemas.openxmlformats.org/officeDocument/2006/relationships" xmlns:a="http://schemas.openxmlformats.org/drawingml/2006/main" r:embed="R110ef338fad54847"/>
+          <a:blip xmlns:r="http://schemas.openxmlformats.org/officeDocument/2006/relationships" xmlns:a="http://schemas.openxmlformats.org/drawingml/2006/main" r:embed="R7d1ac4bf03b3430b"/>
           <a:stretch xmlns:a="http://schemas.openxmlformats.org/drawingml/2006/main">
             <a:fillRect l="0" t="0" r="0" b="0"/>
           </a:stretch>
@@ -21038,7 +21038,7 @@
           <p:nvPr/>
         </p:nvPicPr>
         <p:blipFill>
-          <a:blip xmlns:r="http://schemas.openxmlformats.org/officeDocument/2006/relationships" xmlns:a="http://schemas.openxmlformats.org/drawingml/2006/main" r:embed="R321af181fd284e2b"/>
+          <a:blip xmlns:r="http://schemas.openxmlformats.org/officeDocument/2006/relationships" xmlns:a="http://schemas.openxmlformats.org/drawingml/2006/main" r:embed="R0d2fb1697a624eef"/>
           <a:stretch xmlns:a="http://schemas.openxmlformats.org/drawingml/2006/main">
             <a:fillRect l="0" t="0" r="0" b="0"/>
           </a:stretch>
@@ -21115,7 +21115,7 @@
           <p:nvPr/>
         </p:nvPicPr>
         <p:blipFill>
-          <a:blip xmlns:r="http://schemas.openxmlformats.org/officeDocument/2006/relationships" xmlns:a="http://schemas.openxmlformats.org/drawingml/2006/main" r:embed="R3499b17868504fcc"/>
+          <a:blip xmlns:r="http://schemas.openxmlformats.org/officeDocument/2006/relationships" xmlns:a="http://schemas.openxmlformats.org/drawingml/2006/main" r:embed="R6eda92d8f73f47f4"/>
           <a:stretch xmlns:a="http://schemas.openxmlformats.org/drawingml/2006/main">
             <a:fillRect l="0" t="0" r="0" b="0"/>
           </a:stretch>
@@ -21192,7 +21192,7 @@
           <p:nvPr/>
         </p:nvPicPr>
         <p:blipFill>
-          <a:blip xmlns:r="http://schemas.openxmlformats.org/officeDocument/2006/relationships" xmlns:a="http://schemas.openxmlformats.org/drawingml/2006/main" r:embed="R220c9584edcd49a9"/>
+          <a:blip xmlns:r="http://schemas.openxmlformats.org/officeDocument/2006/relationships" xmlns:a="http://schemas.openxmlformats.org/drawingml/2006/main" r:embed="R021f9f890be548c4"/>
           <a:stretch xmlns:a="http://schemas.openxmlformats.org/drawingml/2006/main">
             <a:fillRect l="0" t="0" r="0" b="0"/>
           </a:stretch>
@@ -21269,7 +21269,7 @@
           <p:nvPr/>
         </p:nvPicPr>
         <p:blipFill>
-          <a:blip xmlns:r="http://schemas.openxmlformats.org/officeDocument/2006/relationships" xmlns:a="http://schemas.openxmlformats.org/drawingml/2006/main" r:embed="Rbadffc35311341e7"/>
+          <a:blip xmlns:r="http://schemas.openxmlformats.org/officeDocument/2006/relationships" xmlns:a="http://schemas.openxmlformats.org/drawingml/2006/main" r:embed="Rcb5b05efe2ea40f4"/>
           <a:stretch xmlns:a="http://schemas.openxmlformats.org/drawingml/2006/main">
             <a:fillRect l="0" t="0" r="0" b="0"/>
           </a:stretch>
@@ -21346,7 +21346,7 @@
           <p:nvPr/>
         </p:nvPicPr>
         <p:blipFill>
-          <a:blip xmlns:r="http://schemas.openxmlformats.org/officeDocument/2006/relationships" xmlns:a="http://schemas.openxmlformats.org/drawingml/2006/main" r:embed="Rc64c353c01cd4946"/>
+          <a:blip xmlns:r="http://schemas.openxmlformats.org/officeDocument/2006/relationships" xmlns:a="http://schemas.openxmlformats.org/drawingml/2006/main" r:embed="R4d7cc3aa90024238"/>
           <a:stretch xmlns:a="http://schemas.openxmlformats.org/drawingml/2006/main">
             <a:fillRect l="0" t="0" r="0" b="0"/>
           </a:stretch>
@@ -21636,7 +21636,7 @@
           <p:nvPr/>
         </p:nvPicPr>
         <p:blipFill>
-          <a:blip xmlns:r="http://schemas.openxmlformats.org/officeDocument/2006/relationships" xmlns:a="http://schemas.openxmlformats.org/drawingml/2006/main" r:embed="R54849a64bad2406d"/>
+          <a:blip xmlns:r="http://schemas.openxmlformats.org/officeDocument/2006/relationships" xmlns:a="http://schemas.openxmlformats.org/drawingml/2006/main" r:embed="R5a40ababaa9b40fa"/>
           <a:stretch xmlns:a="http://schemas.openxmlformats.org/drawingml/2006/main">
             <a:fillRect l="0" t="0" r="0" b="0"/>
           </a:stretch>
@@ -21819,7 +21819,7 @@
           <p:nvPr/>
         </p:nvPicPr>
         <p:blipFill>
-          <a:blip xmlns:r="http://schemas.openxmlformats.org/officeDocument/2006/relationships" xmlns:a="http://schemas.openxmlformats.org/drawingml/2006/main" r:embed="Refa5e47de47540f1"/>
+          <a:blip xmlns:r="http://schemas.openxmlformats.org/officeDocument/2006/relationships" xmlns:a="http://schemas.openxmlformats.org/drawingml/2006/main" r:embed="R95f80da9168e4ba1"/>
           <a:stretch xmlns:a="http://schemas.openxmlformats.org/drawingml/2006/main">
             <a:fillRect l="0" t="0" r="0" b="0"/>
           </a:stretch>
@@ -21843,7 +21843,7 @@
           <p:nvPr/>
         </p:nvPicPr>
         <p:blipFill>
-          <a:blip xmlns:r="http://schemas.openxmlformats.org/officeDocument/2006/relationships" xmlns:a="http://schemas.openxmlformats.org/drawingml/2006/main" r:embed="R394f1f5c81bd421d"/>
+          <a:blip xmlns:r="http://schemas.openxmlformats.org/officeDocument/2006/relationships" xmlns:a="http://schemas.openxmlformats.org/drawingml/2006/main" r:embed="R810ed055e1a2468e"/>
           <a:stretch xmlns:a="http://schemas.openxmlformats.org/drawingml/2006/main">
             <a:fillRect l="0" t="0" r="0" b="0"/>
           </a:stretch>
@@ -22768,7 +22768,7 @@
           <p:nvPr/>
         </p:nvPicPr>
         <p:blipFill>
-          <a:blip xmlns:r="http://schemas.openxmlformats.org/officeDocument/2006/relationships" xmlns:a="http://schemas.openxmlformats.org/drawingml/2006/main" r:embed="Rdb1f8ee77a9742f1"/>
+          <a:blip xmlns:r="http://schemas.openxmlformats.org/officeDocument/2006/relationships" xmlns:a="http://schemas.openxmlformats.org/drawingml/2006/main" r:embed="Rc27f60b27caf4cb3"/>
           <a:stretch xmlns:a="http://schemas.openxmlformats.org/drawingml/2006/main">
             <a:fillRect l="0" t="0" r="0" b="0"/>
           </a:stretch>
@@ -22792,7 +22792,7 @@
           <p:nvPr/>
         </p:nvPicPr>
         <p:blipFill>
-          <a:blip xmlns:r="http://schemas.openxmlformats.org/officeDocument/2006/relationships" xmlns:a="http://schemas.openxmlformats.org/drawingml/2006/main" r:embed="Re5e3b62205e64d70"/>
+          <a:blip xmlns:r="http://schemas.openxmlformats.org/officeDocument/2006/relationships" xmlns:a="http://schemas.openxmlformats.org/drawingml/2006/main" r:embed="R5dcf54ccbf094cdc"/>
           <a:stretch xmlns:a="http://schemas.openxmlformats.org/drawingml/2006/main">
             <a:fillRect l="0" t="0" r="0" b="0"/>
           </a:stretch>
@@ -23028,7 +23028,7 @@
           <p:nvPr/>
         </p:nvPicPr>
         <p:blipFill>
-          <a:blip xmlns:r="http://schemas.openxmlformats.org/officeDocument/2006/relationships" xmlns:a="http://schemas.openxmlformats.org/drawingml/2006/main" r:embed="Rb505ca63495e4fd4"/>
+          <a:blip xmlns:r="http://schemas.openxmlformats.org/officeDocument/2006/relationships" xmlns:a="http://schemas.openxmlformats.org/drawingml/2006/main" r:embed="R3a84a4bfa56643a4"/>
           <a:stretch xmlns:a="http://schemas.openxmlformats.org/drawingml/2006/main">
             <a:fillRect l="0" t="0" r="0" b="0"/>
           </a:stretch>
@@ -23105,7 +23105,7 @@
           <p:nvPr/>
         </p:nvPicPr>
         <p:blipFill>
-          <a:blip xmlns:r="http://schemas.openxmlformats.org/officeDocument/2006/relationships" xmlns:a="http://schemas.openxmlformats.org/drawingml/2006/main" r:embed="Rd87f4f909c714f6a"/>
+          <a:blip xmlns:r="http://schemas.openxmlformats.org/officeDocument/2006/relationships" xmlns:a="http://schemas.openxmlformats.org/drawingml/2006/main" r:embed="Rcfe6a799e48846d0"/>
           <a:stretch xmlns:a="http://schemas.openxmlformats.org/drawingml/2006/main">
             <a:fillRect l="0" t="0" r="0" b="0"/>
           </a:stretch>
@@ -23182,7 +23182,7 @@
           <p:nvPr/>
         </p:nvPicPr>
         <p:blipFill>
-          <a:blip xmlns:r="http://schemas.openxmlformats.org/officeDocument/2006/relationships" xmlns:a="http://schemas.openxmlformats.org/drawingml/2006/main" r:embed="R62159e2fd47d4098"/>
+          <a:blip xmlns:r="http://schemas.openxmlformats.org/officeDocument/2006/relationships" xmlns:a="http://schemas.openxmlformats.org/drawingml/2006/main" r:embed="R8d2982ccc0bb46dd"/>
           <a:stretch xmlns:a="http://schemas.openxmlformats.org/drawingml/2006/main">
             <a:fillRect l="0" t="0" r="0" b="0"/>
           </a:stretch>
@@ -23259,7 +23259,7 @@
           <p:nvPr/>
         </p:nvPicPr>
         <p:blipFill>
-          <a:blip xmlns:r="http://schemas.openxmlformats.org/officeDocument/2006/relationships" xmlns:a="http://schemas.openxmlformats.org/drawingml/2006/main" r:embed="Rdc17f9586ec34806"/>
+          <a:blip xmlns:r="http://schemas.openxmlformats.org/officeDocument/2006/relationships" xmlns:a="http://schemas.openxmlformats.org/drawingml/2006/main" r:embed="R7971d087251a404d"/>
           <a:stretch xmlns:a="http://schemas.openxmlformats.org/drawingml/2006/main">
             <a:fillRect l="0" t="0" r="0" b="0"/>
           </a:stretch>
@@ -23336,7 +23336,7 @@
           <p:nvPr/>
         </p:nvPicPr>
         <p:blipFill>
-          <a:blip xmlns:r="http://schemas.openxmlformats.org/officeDocument/2006/relationships" xmlns:a="http://schemas.openxmlformats.org/drawingml/2006/main" r:embed="R225d153ceb994231"/>
+          <a:blip xmlns:r="http://schemas.openxmlformats.org/officeDocument/2006/relationships" xmlns:a="http://schemas.openxmlformats.org/drawingml/2006/main" r:embed="R4fbae96a2bb14af9"/>
           <a:stretch xmlns:a="http://schemas.openxmlformats.org/drawingml/2006/main">
             <a:fillRect l="0" t="0" r="0" b="0"/>
           </a:stretch>
@@ -23413,7 +23413,7 @@
           <p:nvPr/>
         </p:nvPicPr>
         <p:blipFill>
-          <a:blip xmlns:r="http://schemas.openxmlformats.org/officeDocument/2006/relationships" xmlns:a="http://schemas.openxmlformats.org/drawingml/2006/main" r:embed="R1df9f519f3d84a1e"/>
+          <a:blip xmlns:r="http://schemas.openxmlformats.org/officeDocument/2006/relationships" xmlns:a="http://schemas.openxmlformats.org/drawingml/2006/main" r:embed="R4f28681ff5b94cad"/>
           <a:stretch xmlns:a="http://schemas.openxmlformats.org/drawingml/2006/main">
             <a:fillRect l="0" t="0" r="0" b="0"/>
           </a:stretch>
@@ -23490,7 +23490,7 @@
           <p:nvPr/>
         </p:nvPicPr>
         <p:blipFill>
-          <a:blip xmlns:r="http://schemas.openxmlformats.org/officeDocument/2006/relationships" xmlns:a="http://schemas.openxmlformats.org/drawingml/2006/main" r:embed="R7a9f75a0b7da4eb5"/>
+          <a:blip xmlns:r="http://schemas.openxmlformats.org/officeDocument/2006/relationships" xmlns:a="http://schemas.openxmlformats.org/drawingml/2006/main" r:embed="Re1f608f3c99b4c6f"/>
           <a:stretch xmlns:a="http://schemas.openxmlformats.org/drawingml/2006/main">
             <a:fillRect l="0" t="0" r="0" b="0"/>
           </a:stretch>
@@ -23780,7 +23780,7 @@
           <p:nvPr/>
         </p:nvPicPr>
         <p:blipFill>
-          <a:blip xmlns:r="http://schemas.openxmlformats.org/officeDocument/2006/relationships" xmlns:a="http://schemas.openxmlformats.org/drawingml/2006/main" r:embed="R5880cd7c33e6466f"/>
+          <a:blip xmlns:r="http://schemas.openxmlformats.org/officeDocument/2006/relationships" xmlns:a="http://schemas.openxmlformats.org/drawingml/2006/main" r:embed="R0360bf52e8694db5"/>
           <a:stretch xmlns:a="http://schemas.openxmlformats.org/drawingml/2006/main">
             <a:fillRect l="0" t="0" r="0" b="0"/>
           </a:stretch>
@@ -23963,7 +23963,7 @@
           <p:nvPr/>
         </p:nvPicPr>
         <p:blipFill>
-          <a:blip xmlns:r="http://schemas.openxmlformats.org/officeDocument/2006/relationships" xmlns:a="http://schemas.openxmlformats.org/drawingml/2006/main" r:embed="R53e2ba2ccce241b4"/>
+          <a:blip xmlns:r="http://schemas.openxmlformats.org/officeDocument/2006/relationships" xmlns:a="http://schemas.openxmlformats.org/drawingml/2006/main" r:embed="Rd8604b5fdb9c43d4"/>
           <a:stretch xmlns:a="http://schemas.openxmlformats.org/drawingml/2006/main">
             <a:fillRect l="0" t="0" r="0" b="0"/>
           </a:stretch>
@@ -23987,7 +23987,7 @@
           <p:nvPr/>
         </p:nvPicPr>
         <p:blipFill>
-          <a:blip xmlns:r="http://schemas.openxmlformats.org/officeDocument/2006/relationships" xmlns:a="http://schemas.openxmlformats.org/drawingml/2006/main" r:embed="Re81943d77f894d0b"/>
+          <a:blip xmlns:r="http://schemas.openxmlformats.org/officeDocument/2006/relationships" xmlns:a="http://schemas.openxmlformats.org/drawingml/2006/main" r:embed="R8402e8cde6be4341"/>
           <a:stretch xmlns:a="http://schemas.openxmlformats.org/drawingml/2006/main">
             <a:fillRect l="0" t="0" r="0" b="0"/>
           </a:stretch>
@@ -24911,7 +24911,7 @@
           <p:nvPr/>
         </p:nvPicPr>
         <p:blipFill>
-          <a:blip xmlns:r="http://schemas.openxmlformats.org/officeDocument/2006/relationships" xmlns:a="http://schemas.openxmlformats.org/drawingml/2006/main" r:embed="Rd956c152ac024b1a"/>
+          <a:blip xmlns:r="http://schemas.openxmlformats.org/officeDocument/2006/relationships" xmlns:a="http://schemas.openxmlformats.org/drawingml/2006/main" r:embed="Ra50fc4e5625c41b9"/>
           <a:stretch xmlns:a="http://schemas.openxmlformats.org/drawingml/2006/main">
             <a:fillRect l="0" t="0" r="0" b="0"/>
           </a:stretch>
@@ -24935,7 +24935,7 @@
           <p:nvPr/>
         </p:nvPicPr>
         <p:blipFill>
-          <a:blip xmlns:r="http://schemas.openxmlformats.org/officeDocument/2006/relationships" xmlns:a="http://schemas.openxmlformats.org/drawingml/2006/main" r:embed="R18f57ccc589341fb"/>
+          <a:blip xmlns:r="http://schemas.openxmlformats.org/officeDocument/2006/relationships" xmlns:a="http://schemas.openxmlformats.org/drawingml/2006/main" r:embed="R7aee2ff3b8094a60"/>
           <a:stretch xmlns:a="http://schemas.openxmlformats.org/drawingml/2006/main">
             <a:fillRect l="0" t="0" r="0" b="0"/>
           </a:stretch>
@@ -25171,7 +25171,7 @@
           <p:nvPr/>
         </p:nvPicPr>
         <p:blipFill>
-          <a:blip xmlns:r="http://schemas.openxmlformats.org/officeDocument/2006/relationships" xmlns:a="http://schemas.openxmlformats.org/drawingml/2006/main" r:embed="Rb93c8210615448bc"/>
+          <a:blip xmlns:r="http://schemas.openxmlformats.org/officeDocument/2006/relationships" xmlns:a="http://schemas.openxmlformats.org/drawingml/2006/main" r:embed="R0d00627ea329479e"/>
           <a:stretch xmlns:a="http://schemas.openxmlformats.org/drawingml/2006/main">
             <a:fillRect l="0" t="0" r="0" b="0"/>
           </a:stretch>
@@ -25248,7 +25248,7 @@
           <p:nvPr/>
         </p:nvPicPr>
         <p:blipFill>
-          <a:blip xmlns:r="http://schemas.openxmlformats.org/officeDocument/2006/relationships" xmlns:a="http://schemas.openxmlformats.org/drawingml/2006/main" r:embed="Rb3d78f4624c24fe0"/>
+          <a:blip xmlns:r="http://schemas.openxmlformats.org/officeDocument/2006/relationships" xmlns:a="http://schemas.openxmlformats.org/drawingml/2006/main" r:embed="Rf356a8754b0547db"/>
           <a:stretch xmlns:a="http://schemas.openxmlformats.org/drawingml/2006/main">
             <a:fillRect l="0" t="0" r="0" b="0"/>
           </a:stretch>
@@ -25325,7 +25325,7 @@
           <p:nvPr/>
         </p:nvPicPr>
         <p:blipFill>
-          <a:blip xmlns:r="http://schemas.openxmlformats.org/officeDocument/2006/relationships" xmlns:a="http://schemas.openxmlformats.org/drawingml/2006/main" r:embed="R0eb25ae020c54bdb"/>
+          <a:blip xmlns:r="http://schemas.openxmlformats.org/officeDocument/2006/relationships" xmlns:a="http://schemas.openxmlformats.org/drawingml/2006/main" r:embed="Ra75cd4b75c22474d"/>
           <a:stretch xmlns:a="http://schemas.openxmlformats.org/drawingml/2006/main">
             <a:fillRect l="0" t="0" r="0" b="0"/>
           </a:stretch>
@@ -25402,7 +25402,7 @@
           <p:nvPr/>
         </p:nvPicPr>
         <p:blipFill>
-          <a:blip xmlns:r="http://schemas.openxmlformats.org/officeDocument/2006/relationships" xmlns:a="http://schemas.openxmlformats.org/drawingml/2006/main" r:embed="Rfc844ccd586748a1"/>
+          <a:blip xmlns:r="http://schemas.openxmlformats.org/officeDocument/2006/relationships" xmlns:a="http://schemas.openxmlformats.org/drawingml/2006/main" r:embed="R287d9566560d4d8f"/>
           <a:stretch xmlns:a="http://schemas.openxmlformats.org/drawingml/2006/main">
             <a:fillRect l="0" t="0" r="0" b="0"/>
           </a:stretch>
@@ -25479,7 +25479,7 @@
           <p:nvPr/>
         </p:nvPicPr>
         <p:blipFill>
-          <a:blip xmlns:r="http://schemas.openxmlformats.org/officeDocument/2006/relationships" xmlns:a="http://schemas.openxmlformats.org/drawingml/2006/main" r:embed="R183d2f8567a44a58"/>
+          <a:blip xmlns:r="http://schemas.openxmlformats.org/officeDocument/2006/relationships" xmlns:a="http://schemas.openxmlformats.org/drawingml/2006/main" r:embed="Rfe506a32dd7f45b9"/>
           <a:stretch xmlns:a="http://schemas.openxmlformats.org/drawingml/2006/main">
             <a:fillRect l="0" t="0" r="0" b="0"/>
           </a:stretch>
@@ -25556,7 +25556,7 @@
           <p:nvPr/>
         </p:nvPicPr>
         <p:blipFill>
-          <a:blip xmlns:r="http://schemas.openxmlformats.org/officeDocument/2006/relationships" xmlns:a="http://schemas.openxmlformats.org/drawingml/2006/main" r:embed="R491a9ee138154ce9"/>
+          <a:blip xmlns:r="http://schemas.openxmlformats.org/officeDocument/2006/relationships" xmlns:a="http://schemas.openxmlformats.org/drawingml/2006/main" r:embed="R747a084772c6427d"/>
           <a:stretch xmlns:a="http://schemas.openxmlformats.org/drawingml/2006/main">
             <a:fillRect l="0" t="0" r="0" b="0"/>
           </a:stretch>
@@ -25633,7 +25633,7 @@
           <p:nvPr/>
         </p:nvPicPr>
         <p:blipFill>
-          <a:blip xmlns:r="http://schemas.openxmlformats.org/officeDocument/2006/relationships" xmlns:a="http://schemas.openxmlformats.org/drawingml/2006/main" r:embed="R1f3b8b1b68574180"/>
+          <a:blip xmlns:r="http://schemas.openxmlformats.org/officeDocument/2006/relationships" xmlns:a="http://schemas.openxmlformats.org/drawingml/2006/main" r:embed="R84ade31d6d15406a"/>
           <a:stretch xmlns:a="http://schemas.openxmlformats.org/drawingml/2006/main">
             <a:fillRect l="0" t="0" r="0" b="0"/>
           </a:stretch>
@@ -25923,7 +25923,7 @@
           <p:nvPr/>
         </p:nvPicPr>
         <p:blipFill>
-          <a:blip xmlns:r="http://schemas.openxmlformats.org/officeDocument/2006/relationships" xmlns:a="http://schemas.openxmlformats.org/drawingml/2006/main" r:embed="Rad4fc4141c654447"/>
+          <a:blip xmlns:r="http://schemas.openxmlformats.org/officeDocument/2006/relationships" xmlns:a="http://schemas.openxmlformats.org/drawingml/2006/main" r:embed="R9f78948e1a954f33"/>
           <a:stretch xmlns:a="http://schemas.openxmlformats.org/drawingml/2006/main">
             <a:fillRect l="0" t="0" r="0" b="0"/>
           </a:stretch>

</xml_diff>